<commit_message>
fix(ods): a cell's runs take its style's and their paragraph style's looks
A spreadsheet sets a cell bold (or its font, size, colour) through the cell's style: its runs were
read from their own spans alone, so a bold header cell read plain, and its paragraph style was not
read either.
</commit_message>
<xml_diff>
--- a/test/generator/baseline/gen.ods.to.pptx.pptx
+++ b/test/generator/baseline/gen.ods.to.pptx.pptx
@@ -167,10 +167,15 @@
                         <a:buNone/>
                       </a:pPr>
                       <a:r>
-                        <a:rPr lang="en-US" sz="1200" dirty="0"/>
+                        <a:rPr lang="en-US" sz="2600" dirty="0">
+                          <a:solidFill>
+                            <a:srgbClr val="17365D"/>
+                          </a:solidFill>
+                          <a:latin typeface="Ubuntu"/>
+                        </a:rPr>
                         <a:t>Demonstration of DOCX support in calibre </a:t>
                       </a:r>
-                      <a:endParaRPr lang="en-US" sz="1200" dirty="0"/>
+                      <a:endParaRPr lang="en-US" sz="2600" dirty="0"/>
                     </a:p>
                   </a:txBody>
                   <a:tcPr>
@@ -236,7 +241,12 @@
                         <a:buNone/>
                       </a:pPr>
                       <a:r>
-                        <a:rPr lang="en-US" sz="1200" dirty="0"/>
+                        <a:rPr lang="en-US" sz="1200" dirty="0">
+                          <a:solidFill>
+                            <a:srgbClr val="000000"/>
+                          </a:solidFill>
+                          <a:latin typeface="Ubuntu"/>
+                        </a:rPr>
                         <a:t>This document demonstrates the ability of the </a:t>
                       </a:r>
                       <a:r>
@@ -249,7 +259,12 @@
                         <a:t>calibre</a:t>
                       </a:r>
                       <a:r>
-                        <a:rPr lang="en-US" sz="1200" dirty="0"/>
+                        <a:rPr lang="en-US" sz="1200" dirty="0">
+                          <a:solidFill>
+                            <a:srgbClr val="000000"/>
+                          </a:solidFill>
+                          <a:latin typeface="Ubuntu"/>
+                        </a:rPr>
                         <a:t> DOCX Input plugin to convert the various typographic features in a Microsoft Word (2007 and newer) document. Convert this document to a modern ebook format, such as AZW3 for Kindles or EPUB for other ebook readers, to see it in action. </a:t>
                       </a:r>
                       <a:endParaRPr lang="en-US" sz="1200" dirty="0"/>
@@ -318,7 +333,12 @@
                         <a:buNone/>
                       </a:pPr>
                       <a:r>
-                        <a:rPr lang="en-US" sz="1200" dirty="0"/>
+                        <a:rPr lang="en-US" sz="1200" dirty="0">
+                          <a:solidFill>
+                            <a:srgbClr val="000000"/>
+                          </a:solidFill>
+                          <a:latin typeface="Ubuntu"/>
+                        </a:rPr>
                         <a:t>There is support for images, tables, lists, footnotes, endnotes, links, dropcaps and various types of text and paragraph level formatting. </a:t>
                       </a:r>
                       <a:endParaRPr lang="en-US" sz="1200" dirty="0"/>
@@ -387,7 +407,12 @@
                         <a:buNone/>
                       </a:pPr>
                       <a:r>
-                        <a:rPr lang="en-US" sz="1200" dirty="0"/>
+                        <a:rPr lang="en-US" sz="1200" dirty="0">
+                          <a:solidFill>
+                            <a:srgbClr val="000000"/>
+                          </a:solidFill>
+                          <a:latin typeface="Ubuntu"/>
+                        </a:rPr>
                         <a:t>To see the DOCX conversion in action, simply add this file to calibre using the </a:t>
                       </a:r>
                       <a:r>
@@ -400,7 +425,12 @@
                         <a:t>“Add Books” </a:t>
                       </a:r>
                       <a:r>
-                        <a:rPr lang="en-US" sz="1200" dirty="0"/>
+                        <a:rPr lang="en-US" sz="1200" dirty="0">
+                          <a:solidFill>
+                            <a:srgbClr val="000000"/>
+                          </a:solidFill>
+                          <a:latin typeface="Ubuntu"/>
+                        </a:rPr>
                         <a:t>button and then click “</a:t>
                       </a:r>
                       <a:r>
@@ -413,7 +443,12 @@
                         <a:t>Convert”. </a:t>
                       </a:r>
                       <a:r>
-                        <a:rPr lang="en-US" sz="1200" dirty="0"/>
+                        <a:rPr lang="en-US" sz="1200" dirty="0">
+                          <a:solidFill>
+                            <a:srgbClr val="000000"/>
+                          </a:solidFill>
+                          <a:latin typeface="Ubuntu"/>
+                        </a:rPr>
                         <a:t> Set the output format in the top right corner of the conversion dialog to EPUB or AZW3 and click </a:t>
                       </a:r>
                       <a:r>
@@ -426,7 +461,12 @@
                         <a:t>“OK”</a:t>
                       </a:r>
                       <a:r>
-                        <a:rPr lang="en-US" sz="1200" dirty="0"/>
+                        <a:rPr lang="en-US" sz="1200" dirty="0">
+                          <a:solidFill>
+                            <a:srgbClr val="000000"/>
+                          </a:solidFill>
+                          <a:latin typeface="Ubuntu"/>
+                        </a:rPr>
                         <a:t>. </a:t>
                       </a:r>
                       <a:endParaRPr lang="en-US" sz="1200" dirty="0"/>
@@ -524,7 +564,12 @@
                         <a:buNone/>
                       </a:pPr>
                       <a:r>
-                        <a:rPr lang="en-US" sz="1200" dirty="0"/>
+                        <a:rPr lang="en-US" sz="1200" dirty="0">
+                          <a:solidFill>
+                            <a:srgbClr val="000000"/>
+                          </a:solidFill>
+                          <a:latin typeface="Ubuntu"/>
+                        </a:rPr>
                         <a:t>One, with a very long line to demonstrate that the hanging indent for the list is working correctly </a:t>
                       </a:r>
                       <a:endParaRPr lang="en-US" sz="1200" dirty="0"/>
@@ -593,7 +638,12 @@
                         <a:buNone/>
                       </a:pPr>
                       <a:r>
-                        <a:rPr lang="en-US" sz="1200" dirty="0"/>
+                        <a:rPr lang="en-US" sz="1200" dirty="0">
+                          <a:solidFill>
+                            <a:srgbClr val="000000"/>
+                          </a:solidFill>
+                          <a:latin typeface="Ubuntu"/>
+                        </a:rPr>
                         <a:t>Two </a:t>
                       </a:r>
                       <a:endParaRPr lang="en-US" sz="1200" dirty="0"/>
@@ -662,7 +712,12 @@
                         <a:buNone/>
                       </a:pPr>
                       <a:r>
-                        <a:rPr lang="en-US" sz="1200" dirty="0"/>
+                        <a:rPr lang="en-US" sz="1200" dirty="0">
+                          <a:solidFill>
+                            <a:srgbClr val="000000"/>
+                          </a:solidFill>
+                          <a:latin typeface="Ubuntu"/>
+                        </a:rPr>
                         <a:t>One </a:t>
                       </a:r>
                       <a:endParaRPr lang="en-US" sz="1200" dirty="0"/>
@@ -731,7 +786,12 @@
                         <a:buNone/>
                       </a:pPr>
                       <a:r>
-                        <a:rPr lang="en-US" sz="1200" dirty="0"/>
+                        <a:rPr lang="en-US" sz="1200" dirty="0">
+                          <a:solidFill>
+                            <a:srgbClr val="000000"/>
+                          </a:solidFill>
+                          <a:latin typeface="Ubuntu"/>
+                        </a:rPr>
                         <a:t>Two </a:t>
                       </a:r>
                       <a:endParaRPr lang="en-US" sz="1200" dirty="0"/>
@@ -800,7 +860,12 @@
                         <a:buNone/>
                       </a:pPr>
                       <a:r>
-                        <a:rPr lang="en-US" sz="1200" dirty="0"/>
+                        <a:rPr lang="en-US" sz="1200" dirty="0">
+                          <a:solidFill>
+                            <a:srgbClr val="000000"/>
+                          </a:solidFill>
+                          <a:latin typeface="Ubuntu"/>
+                        </a:rPr>
                         <a:t>Three </a:t>
                       </a:r>
                       <a:endParaRPr lang="en-US" sz="1200" dirty="0"/>
@@ -869,7 +934,12 @@
                         <a:buNone/>
                       </a:pPr>
                       <a:r>
-                        <a:rPr lang="en-US" sz="1200" dirty="0"/>
+                        <a:rPr lang="en-US" sz="1200" dirty="0">
+                          <a:solidFill>
+                            <a:srgbClr val="000000"/>
+                          </a:solidFill>
+                          <a:latin typeface="Ubuntu"/>
+                        </a:rPr>
                         <a:t>Four with a very long line to demonstrate that the hanging indent for the list is working correctly. </a:t>
                       </a:r>
                       <a:endParaRPr lang="en-US" sz="1200" dirty="0"/>
@@ -938,7 +1008,12 @@
                         <a:buNone/>
                       </a:pPr>
                       <a:r>
-                        <a:rPr lang="en-US" sz="1200" dirty="0"/>
+                        <a:rPr lang="en-US" sz="1200" dirty="0">
+                          <a:solidFill>
+                            <a:srgbClr val="000000"/>
+                          </a:solidFill>
+                          <a:latin typeface="Ubuntu"/>
+                        </a:rPr>
                         <a:t>Five </a:t>
                       </a:r>
                       <a:endParaRPr lang="en-US" sz="1200" dirty="0"/>
@@ -1075,7 +1150,12 @@
                         <a:buNone/>
                       </a:pPr>
                       <a:r>
-                        <a:rPr lang="en-US" sz="1200" dirty="0"/>
+                        <a:rPr lang="en-US" sz="1200" dirty="0">
+                          <a:solidFill>
+                            <a:srgbClr val="000000"/>
+                          </a:solidFill>
+                          <a:latin typeface="Ubuntu"/>
+                        </a:rPr>
                         <a:t>We end with a fancy calendar, note how much of the original formatting is preserved. Note that this table will only display correctly on relatively wide screens. In general, very wide tables or tables whose cells have fixed width requirements don’t fare well in ebooks. </a:t>
                       </a:r>
                       <a:endParaRPr lang="en-US" sz="1200" dirty="0"/>
@@ -1492,7 +1572,12 @@
                         <a:buNone/>
                       </a:pPr>
                       <a:r>
-                        <a:rPr lang="en-US" sz="1200" dirty="0"/>
+                        <a:rPr lang="en-US" sz="1200" dirty="0">
+                          <a:solidFill>
+                            <a:srgbClr val="365F91"/>
+                          </a:solidFill>
+                          <a:latin typeface="Ubuntu"/>
+                        </a:rPr>
                         <a:t>23 </a:t>
                       </a:r>
                       <a:endParaRPr lang="en-US" sz="1200" dirty="0"/>
@@ -1564,7 +1649,12 @@
                         <a:buNone/>
                       </a:pPr>
                       <a:r>
-                        <a:rPr lang="en-US" sz="1200" dirty="0"/>
+                        <a:rPr lang="en-US" sz="1200" dirty="0">
+                          <a:solidFill>
+                            <a:srgbClr val="7F7F7F"/>
+                          </a:solidFill>
+                          <a:latin typeface="Ubuntu"/>
+                        </a:rPr>
                         <a:t>24 </a:t>
                       </a:r>
                       <a:endParaRPr lang="en-US" sz="1200" dirty="0"/>
@@ -1636,7 +1726,12 @@
                         <a:buNone/>
                       </a:pPr>
                       <a:r>
-                        <a:rPr lang="en-US" sz="1200" dirty="0"/>
+                        <a:rPr lang="en-US" sz="1200" dirty="0">
+                          <a:solidFill>
+                            <a:srgbClr val="7F7F7F"/>
+                          </a:solidFill>
+                          <a:latin typeface="Ubuntu"/>
+                        </a:rPr>
                         <a:t>25 </a:t>
                       </a:r>
                       <a:endParaRPr lang="en-US" sz="1200" dirty="0"/>
@@ -1708,7 +1803,12 @@
                         <a:buNone/>
                       </a:pPr>
                       <a:r>
-                        <a:rPr lang="en-US" sz="1200" dirty="0"/>
+                        <a:rPr lang="en-US" sz="1200" dirty="0">
+                          <a:solidFill>
+                            <a:srgbClr val="7F7F7F"/>
+                          </a:solidFill>
+                          <a:latin typeface="Ubuntu"/>
+                        </a:rPr>
                         <a:t>26 </a:t>
                       </a:r>
                       <a:endParaRPr lang="en-US" sz="1200" dirty="0"/>
@@ -1780,7 +1880,12 @@
                         <a:buNone/>
                       </a:pPr>
                       <a:r>
-                        <a:rPr lang="en-US" sz="1200" dirty="0"/>
+                        <a:rPr lang="en-US" sz="1200" dirty="0">
+                          <a:solidFill>
+                            <a:srgbClr val="7F7F7F"/>
+                          </a:solidFill>
+                          <a:latin typeface="Ubuntu"/>
+                        </a:rPr>
                         <a:t>27 </a:t>
                       </a:r>
                       <a:endParaRPr lang="en-US" sz="1200" dirty="0"/>
@@ -1852,7 +1957,12 @@
                         <a:buNone/>
                       </a:pPr>
                       <a:r>
-                        <a:rPr lang="en-US" sz="1200" dirty="0"/>
+                        <a:rPr lang="en-US" sz="1200" dirty="0">
+                          <a:solidFill>
+                            <a:srgbClr val="7F7F7F"/>
+                          </a:solidFill>
+                          <a:latin typeface="Ubuntu"/>
+                        </a:rPr>
                         <a:t>28 </a:t>
                       </a:r>
                       <a:endParaRPr lang="en-US" sz="1200" dirty="0"/>
@@ -1924,7 +2034,12 @@
                         <a:buNone/>
                       </a:pPr>
                       <a:r>
-                        <a:rPr lang="en-US" sz="1200" dirty="0"/>
+                        <a:rPr lang="en-US" sz="1200" dirty="0">
+                          <a:solidFill>
+                            <a:srgbClr val="7F7F7F"/>
+                          </a:solidFill>
+                          <a:latin typeface="Ubuntu"/>
+                        </a:rPr>
                         <a:t>29 </a:t>
                       </a:r>
                       <a:endParaRPr lang="en-US" sz="1200" dirty="0"/>
@@ -2466,7 +2581,12 @@
                         <a:buNone/>
                       </a:pPr>
                       <a:r>
-                        <a:rPr lang="en-US" sz="1200" dirty="0"/>
+                        <a:rPr lang="en-US" sz="1200" dirty="0">
+                          <a:solidFill>
+                            <a:srgbClr val="365F91"/>
+                          </a:solidFill>
+                          <a:latin typeface="Ubuntu"/>
+                        </a:rPr>
                         <a:t>30 </a:t>
                       </a:r>
                       <a:endParaRPr lang="en-US" sz="1200" dirty="0"/>
@@ -2538,7 +2658,12 @@
                         <a:buNone/>
                       </a:pPr>
                       <a:r>
-                        <a:rPr lang="en-US" sz="1200" dirty="0"/>
+                        <a:rPr lang="en-US" sz="1200" dirty="0">
+                          <a:solidFill>
+                            <a:srgbClr val="7F7F7F"/>
+                          </a:solidFill>
+                          <a:latin typeface="Ubuntu"/>
+                        </a:rPr>
                         <a:t>31 </a:t>
                       </a:r>
                       <a:endParaRPr lang="en-US" sz="1200" dirty="0"/>
@@ -3031,10 +3156,15 @@
                         <a:buNone/>
                       </a:pPr>
                       <a:r>
-                        <a:rPr lang="en-US" sz="1200" dirty="0"/>
+                        <a:rPr lang="en-US" sz="1400" b="1" dirty="0">
+                          <a:solidFill>
+                            <a:srgbClr val="365F91"/>
+                          </a:solidFill>
+                          <a:latin typeface="Ubuntu"/>
+                        </a:rPr>
                         <a:t>Structural Elements </a:t>
                       </a:r>
-                      <a:endParaRPr lang="en-US" sz="1200" dirty="0"/>
+                      <a:endParaRPr lang="en-US" sz="1400" dirty="0"/>
                     </a:p>
                   </a:txBody>
                   <a:tcPr>
@@ -3071,7 +3201,12 @@
                         <a:buNone/>
                       </a:pPr>
                       <a:r>
-                        <a:rPr lang="en-US" sz="1200" dirty="0"/>
+                        <a:rPr lang="en-US" sz="1200" dirty="0">
+                          <a:solidFill>
+                            <a:srgbClr val="000000"/>
+                          </a:solidFill>
+                          <a:latin typeface="Ubuntu"/>
+                        </a:rPr>
                         <a:t>Miscellaneous structural elements you can add to your document, like footnotes, endnotes, dropcaps and the like.  </a:t>
                       </a:r>
                       <a:endParaRPr lang="en-US" sz="1200" dirty="0"/>
@@ -3111,10 +3246,15 @@
                         <a:buNone/>
                       </a:pPr>
                       <a:r>
-                        <a:rPr lang="en-US" sz="1200" dirty="0"/>
+                        <a:rPr lang="en-US" sz="1300" b="1" dirty="0">
+                          <a:solidFill>
+                            <a:srgbClr val="4F81BD"/>
+                          </a:solidFill>
+                          <a:latin typeface="Ubuntu"/>
+                        </a:rPr>
                         <a:t>Footnotes &amp; Endnotes </a:t>
                       </a:r>
-                      <a:endParaRPr lang="en-US" sz="1200" dirty="0"/>
+                      <a:endParaRPr lang="en-US" sz="1300" dirty="0"/>
                     </a:p>
                   </a:txBody>
                   <a:tcPr>
@@ -3151,7 +3291,12 @@
                         <a:buNone/>
                       </a:pPr>
                       <a:r>
-                        <a:rPr lang="en-US" sz="1200" dirty="0"/>
+                        <a:rPr lang="en-US" sz="1200" dirty="0">
+                          <a:solidFill>
+                            <a:srgbClr val="000000"/>
+                          </a:solidFill>
+                          <a:latin typeface="Ubuntu"/>
+                        </a:rPr>
                         <a:t>Footnotes</a:t>
                       </a:r>
                       <a:r>
@@ -3164,7 +3309,12 @@
                         <a:t>1</a:t>
                       </a:r>
                       <a:r>
-                        <a:rPr lang="en-US" sz="1200" dirty="0"/>
+                        <a:rPr lang="en-US" sz="1200" dirty="0">
+                          <a:solidFill>
+                            <a:srgbClr val="000000"/>
+                          </a:solidFill>
+                          <a:latin typeface="Ubuntu"/>
+                        </a:rPr>
                         <a:t> and endnotes</a:t>
                       </a:r>
                       <a:r>
@@ -3177,10 +3327,15 @@
                         <a:t>i</a:t>
                       </a:r>
                       <a:r>
-                        <a:rPr lang="en-US" sz="1200" dirty="0"/>
+                        <a:rPr lang="en-US" sz="1200" dirty="0">
+                          <a:solidFill>
+                            <a:srgbClr val="000000"/>
+                          </a:solidFill>
+                          <a:latin typeface="Ubuntu"/>
+                        </a:rPr>
                         <a:t> are automatically recognized and both are converted to endnotes, with backlinks for maximum ease of use in ebook devices. </a:t>
                       </a:r>
-                      <a:endParaRPr lang="en-US" sz="900" dirty="0"/>
+                      <a:endParaRPr lang="en-US" sz="1200" dirty="0"/>
                     </a:p>
                   </a:txBody>
                   <a:tcPr>
@@ -3217,10 +3372,15 @@
                         <a:buNone/>
                       </a:pPr>
                       <a:r>
-                        <a:rPr lang="en-US" sz="1200" dirty="0"/>
+                        <a:rPr lang="en-US" sz="1300" b="1" dirty="0">
+                          <a:solidFill>
+                            <a:srgbClr val="4F81BD"/>
+                          </a:solidFill>
+                          <a:latin typeface="Ubuntu"/>
+                        </a:rPr>
                         <a:t>Dropcaps </a:t>
                       </a:r>
-                      <a:endParaRPr lang="en-US" sz="1200" dirty="0"/>
+                      <a:endParaRPr lang="en-US" sz="1300" dirty="0"/>
                     </a:p>
                   </a:txBody>
                   <a:tcPr>
@@ -3257,10 +3417,15 @@
                         <a:buNone/>
                       </a:pPr>
                       <a:r>
-                        <a:rPr lang="en-US" sz="1200" dirty="0"/>
+                        <a:rPr lang="en-US" sz="5800" dirty="0">
+                          <a:solidFill>
+                            <a:srgbClr val="000000"/>
+                          </a:solidFill>
+                          <a:latin typeface="Ubuntu"/>
+                        </a:rPr>
                         <a:t>D </a:t>
                       </a:r>
-                      <a:endParaRPr lang="en-US" sz="1200" dirty="0"/>
+                      <a:endParaRPr lang="en-US" sz="5800" dirty="0"/>
                     </a:p>
                   </a:txBody>
                   <a:tcPr>
@@ -3297,7 +3462,12 @@
                         <a:buNone/>
                       </a:pPr>
                       <a:r>
-                        <a:rPr lang="en-US" sz="1200" dirty="0"/>
+                        <a:rPr lang="en-US" sz="1200" dirty="0">
+                          <a:solidFill>
+                            <a:srgbClr val="000000"/>
+                          </a:solidFill>
+                          <a:latin typeface="Ubuntu"/>
+                        </a:rPr>
                         <a:t>rop caps are used to emphasize the leading paragraph at the start of a section. In Word it is possible to specify how many lines of text a drop-cap should use. </a:t>
                       </a:r>
                       <a:endParaRPr lang="en-US" sz="1200" dirty="0"/>
@@ -3337,10 +3507,15 @@
                         <a:buNone/>
                       </a:pPr>
                       <a:r>
-                        <a:rPr lang="en-US" sz="1200" dirty="0"/>
+                        <a:rPr lang="en-US" sz="1300" b="1" dirty="0">
+                          <a:solidFill>
+                            <a:srgbClr val="4F81BD"/>
+                          </a:solidFill>
+                          <a:latin typeface="Ubuntu"/>
+                        </a:rPr>
                         <a:t>Links </a:t>
                       </a:r>
-                      <a:endParaRPr lang="en-US" sz="1200" dirty="0"/>
+                      <a:endParaRPr lang="en-US" sz="1300" dirty="0"/>
                     </a:p>
                   </a:txBody>
                   <a:tcPr>
@@ -3377,7 +3552,12 @@
                         <a:buNone/>
                       </a:pPr>
                       <a:r>
-                        <a:rPr lang="en-US" sz="1200" dirty="0"/>
+                        <a:rPr lang="en-US" sz="1200" dirty="0">
+                          <a:solidFill>
+                            <a:srgbClr val="000000"/>
+                          </a:solidFill>
+                          <a:latin typeface="Ubuntu"/>
+                        </a:rPr>
                         <a:t>Two kinds of links are possible, those that refer to an external website and those that refer to locations inside the document itself. Both are supported by calibre. For example, here is a link pointing to the </a:t>
                       </a:r>
                       <a:r>
@@ -3390,7 +3570,12 @@
                         <a:t>calibre download page</a:t>
                       </a:r>
                       <a:r>
-                        <a:rPr lang="en-US" sz="1200" dirty="0"/>
+                        <a:rPr lang="en-US" sz="1200" dirty="0">
+                          <a:solidFill>
+                            <a:srgbClr val="000000"/>
+                          </a:solidFill>
+                          <a:latin typeface="Ubuntu"/>
+                        </a:rPr>
                         <a:t>. Then we have a link that points back to the section on </a:t>
                       </a:r>
                       <a:r>
@@ -3403,7 +3588,12 @@
                         <a:t>paragraph level formatting</a:t>
                       </a:r>
                       <a:r>
-                        <a:rPr lang="en-US" sz="1200" dirty="0"/>
+                        <a:rPr lang="en-US" sz="1200" dirty="0">
+                          <a:solidFill>
+                            <a:srgbClr val="000000"/>
+                          </a:solidFill>
+                          <a:latin typeface="Ubuntu"/>
+                        </a:rPr>
                         <a:t> in this document. </a:t>
                       </a:r>
                       <a:endParaRPr lang="en-US" sz="1200" dirty="0"/>
@@ -3527,10 +3717,15 @@
                         <a:buNone/>
                       </a:pPr>
                       <a:r>
-                        <a:rPr lang="en-US" sz="1200" dirty="0"/>
+                        <a:rPr lang="en-US" sz="1400" b="1" dirty="0">
+                          <a:solidFill>
+                            <a:srgbClr val="365F91"/>
+                          </a:solidFill>
+                          <a:latin typeface="Ubuntu"/>
+                        </a:rPr>
                         <a:t>Images </a:t>
                       </a:r>
-                      <a:endParaRPr lang="en-US" sz="1200" dirty="0"/>
+                      <a:endParaRPr lang="en-US" sz="1400" dirty="0"/>
                     </a:p>
                   </a:txBody>
                   <a:tcPr>
@@ -3567,7 +3762,12 @@
                         <a:buNone/>
                       </a:pPr>
                       <a:r>
-                        <a:rPr lang="en-US" sz="1200" dirty="0"/>
+                        <a:rPr lang="en-US" sz="1200" dirty="0">
+                          <a:solidFill>
+                            <a:srgbClr val="000000"/>
+                          </a:solidFill>
+                          <a:latin typeface="Ubuntu"/>
+                        </a:rPr>
                         <a:t>Centered images like this are useful for large pictures that should be a focus of attention.  </a:t>
                       </a:r>
                       <a:endParaRPr lang="en-US" sz="1200" dirty="0"/>
@@ -3643,7 +3843,12 @@
                         <a:buNone/>
                       </a:pPr>
                       <a:r>
-                        <a:rPr lang="en-US" sz="1200" dirty="0"/>
+                        <a:rPr lang="en-US" sz="1200" dirty="0">
+                          <a:solidFill>
+                            <a:srgbClr val="000000"/>
+                          </a:solidFill>
+                          <a:latin typeface="Ubuntu"/>
+                        </a:rPr>
                         <a:t>There is no analogous technology in ebooks, so the conversion will usually end up placing the image either centered or floating close to the point in the text where it was </a:t>
                       </a:r>
                       <a:r>
@@ -3656,7 +3861,12 @@
                         <a:t>inserted</a:t>
                       </a:r>
                       <a:r>
-                        <a:rPr lang="en-US" sz="1200" dirty="0"/>
+                        <a:rPr lang="en-US" sz="1200" dirty="0">
+                          <a:solidFill>
+                            <a:srgbClr val="000000"/>
+                          </a:solidFill>
+                          <a:latin typeface="Ubuntu"/>
+                        </a:rPr>
                         <a:t>, not necessarily where it appears on the page in Word. </a:t>
                       </a:r>
                       <a:endParaRPr lang="en-US" sz="1200" dirty="0"/>
@@ -3866,10 +4076,15 @@
                         <a:buNone/>
                       </a:pPr>
                       <a:r>
-                        <a:rPr lang="en-US" sz="1200" dirty="0"/>
+                        <a:rPr lang="en-US" sz="1400" b="1" dirty="0">
+                          <a:solidFill>
+                            <a:srgbClr val="365F91"/>
+                          </a:solidFill>
+                          <a:latin typeface="Ubuntu"/>
+                        </a:rPr>
                         <a:t>Lists </a:t>
                       </a:r>
-                      <a:endParaRPr lang="en-US" sz="1200" dirty="0"/>
+                      <a:endParaRPr lang="en-US" sz="1400" dirty="0"/>
                     </a:p>
                   </a:txBody>
                   <a:tcPr>
@@ -3935,7 +4150,12 @@
                         <a:buNone/>
                       </a:pPr>
                       <a:r>
-                        <a:rPr lang="en-US" sz="1200" dirty="0"/>
+                        <a:rPr lang="en-US" sz="1200" dirty="0">
+                          <a:solidFill>
+                            <a:srgbClr val="000000"/>
+                          </a:solidFill>
+                          <a:latin typeface="Ubuntu"/>
+                        </a:rPr>
                         <a:t>All types of lists are supported by the conversion, with the exception of lists that use fancy bullets, these get converted to regular bullets. </a:t>
                       </a:r>
                       <a:endParaRPr lang="en-US" sz="1200" dirty="0"/>
@@ -4004,10 +4224,15 @@
                         <a:buNone/>
                       </a:pPr>
                       <a:r>
-                        <a:rPr lang="en-US" sz="1200" dirty="0"/>
+                        <a:rPr lang="en-US" sz="1300" b="1" dirty="0">
+                          <a:solidFill>
+                            <a:srgbClr val="4F81BD"/>
+                          </a:solidFill>
+                          <a:latin typeface="Ubuntu"/>
+                        </a:rPr>
                         <a:t>Bulleted List </a:t>
                       </a:r>
-                      <a:endParaRPr lang="en-US" sz="1200" dirty="0"/>
+                      <a:endParaRPr lang="en-US" sz="1300" dirty="0"/>
                     </a:p>
                   </a:txBody>
                   <a:tcPr>
@@ -4073,7 +4298,12 @@
                         <a:buNone/>
                       </a:pPr>
                       <a:r>
-                        <a:rPr lang="en-US" sz="1200" dirty="0"/>
+                        <a:rPr lang="en-US" sz="1200" dirty="0">
+                          <a:solidFill>
+                            <a:srgbClr val="000000"/>
+                          </a:solidFill>
+                          <a:latin typeface="Ubuntu"/>
+                        </a:rPr>
                         <a:t>One </a:t>
                       </a:r>
                       <a:endParaRPr lang="en-US" sz="1200" dirty="0"/>
@@ -4142,7 +4372,12 @@
                         <a:buNone/>
                       </a:pPr>
                       <a:r>
-                        <a:rPr lang="en-US" sz="1200" dirty="0"/>
+                        <a:rPr lang="en-US" sz="1200" dirty="0">
+                          <a:solidFill>
+                            <a:srgbClr val="000000"/>
+                          </a:solidFill>
+                          <a:latin typeface="Ubuntu"/>
+                        </a:rPr>
                         <a:t>Two </a:t>
                       </a:r>
                       <a:endParaRPr lang="en-US" sz="1200" dirty="0"/>
@@ -4211,10 +4446,15 @@
                         <a:buNone/>
                       </a:pPr>
                       <a:r>
-                        <a:rPr lang="en-US" sz="1200" dirty="0"/>
+                        <a:rPr lang="en-US" sz="1300" b="1" dirty="0">
+                          <a:solidFill>
+                            <a:srgbClr val="4F81BD"/>
+                          </a:solidFill>
+                          <a:latin typeface="Ubuntu"/>
+                        </a:rPr>
                         <a:t>Numbered List </a:t>
                       </a:r>
-                      <a:endParaRPr lang="en-US" sz="1200" dirty="0"/>
+                      <a:endParaRPr lang="en-US" sz="1300" dirty="0"/>
                     </a:p>
                   </a:txBody>
                   <a:tcPr>
@@ -4280,7 +4520,12 @@
                         <a:buNone/>
                       </a:pPr>
                       <a:r>
-                        <a:rPr lang="en-US" sz="1200" dirty="0"/>
+                        <a:rPr lang="en-US" sz="1200" dirty="0">
+                          <a:solidFill>
+                            <a:srgbClr val="000000"/>
+                          </a:solidFill>
+                          <a:latin typeface="Ubuntu"/>
+                        </a:rPr>
                         <a:t>1</a:t>
                       </a:r>
                       <a:endParaRPr lang="en-US" sz="1200" dirty="0"/>
@@ -4318,7 +4563,12 @@
                         <a:buNone/>
                       </a:pPr>
                       <a:r>
-                        <a:rPr lang="en-US" sz="1200" dirty="0"/>
+                        <a:rPr lang="en-US" sz="1200" dirty="0">
+                          <a:solidFill>
+                            <a:srgbClr val="000000"/>
+                          </a:solidFill>
+                          <a:latin typeface="Ubuntu"/>
+                        </a:rPr>
                         <a:t>One, with a very long line to demonstrate that the hanging indent for the list is working correctly </a:t>
                       </a:r>
                       <a:endParaRPr lang="en-US" sz="1200" dirty="0"/>
@@ -4358,7 +4608,12 @@
                         <a:buNone/>
                       </a:pPr>
                       <a:r>
-                        <a:rPr lang="en-US" sz="1200" dirty="0"/>
+                        <a:rPr lang="en-US" sz="1200" dirty="0">
+                          <a:solidFill>
+                            <a:srgbClr val="000000"/>
+                          </a:solidFill>
+                          <a:latin typeface="Ubuntu"/>
+                        </a:rPr>
                         <a:t>2</a:t>
                       </a:r>
                       <a:endParaRPr lang="en-US" sz="1200" dirty="0"/>
@@ -4396,7 +4651,12 @@
                         <a:buNone/>
                       </a:pPr>
                       <a:r>
-                        <a:rPr lang="en-US" sz="1200" dirty="0"/>
+                        <a:rPr lang="en-US" sz="1200" dirty="0">
+                          <a:solidFill>
+                            <a:srgbClr val="000000"/>
+                          </a:solidFill>
+                          <a:latin typeface="Ubuntu"/>
+                        </a:rPr>
                         <a:t>Two </a:t>
                       </a:r>
                       <a:endParaRPr lang="en-US" sz="1200" dirty="0"/>
@@ -4436,10 +4696,15 @@
                         <a:buNone/>
                       </a:pPr>
                       <a:r>
-                        <a:rPr lang="en-US" sz="1200" dirty="0"/>
+                        <a:rPr lang="en-US" sz="1300" b="1" dirty="0">
+                          <a:solidFill>
+                            <a:srgbClr val="4F81BD"/>
+                          </a:solidFill>
+                          <a:latin typeface="Ubuntu"/>
+                        </a:rPr>
                         <a:t>Multi-level Lists </a:t>
                       </a:r>
-                      <a:endParaRPr lang="en-US" sz="1200" dirty="0"/>
+                      <a:endParaRPr lang="en-US" sz="1300" dirty="0"/>
                     </a:p>
                   </a:txBody>
                   <a:tcPr>
@@ -4505,7 +4770,12 @@
                         <a:buNone/>
                       </a:pPr>
                       <a:r>
-                        <a:rPr lang="en-US" sz="1200" dirty="0"/>
+                        <a:rPr lang="en-US" sz="1200" dirty="0">
+                          <a:solidFill>
+                            <a:srgbClr val="000000"/>
+                          </a:solidFill>
+                          <a:latin typeface="Ubuntu"/>
+                        </a:rPr>
                         <a:t>1</a:t>
                       </a:r>
                       <a:endParaRPr lang="en-US" sz="1200" dirty="0"/>
@@ -4543,7 +4813,12 @@
                         <a:buNone/>
                       </a:pPr>
                       <a:r>
-                        <a:rPr lang="en-US" sz="1200" dirty="0"/>
+                        <a:rPr lang="en-US" sz="1200" dirty="0">
+                          <a:solidFill>
+                            <a:srgbClr val="000000"/>
+                          </a:solidFill>
+                          <a:latin typeface="Ubuntu"/>
+                        </a:rPr>
                         <a:t>One </a:t>
                       </a:r>
                       <a:endParaRPr lang="en-US" sz="1200" dirty="0"/>
@@ -4583,7 +4858,12 @@
                         <a:buNone/>
                       </a:pPr>
                       <a:r>
-                        <a:rPr lang="en-US" sz="1200" dirty="0"/>
+                        <a:rPr lang="en-US" sz="1200" dirty="0">
+                          <a:solidFill>
+                            <a:srgbClr val="000000"/>
+                          </a:solidFill>
+                          <a:latin typeface="Ubuntu"/>
+                        </a:rPr>
                         <a:t>1</a:t>
                       </a:r>
                       <a:endParaRPr lang="en-US" sz="1200" dirty="0"/>
@@ -4621,7 +4901,12 @@
                         <a:buNone/>
                       </a:pPr>
                       <a:r>
-                        <a:rPr lang="en-US" sz="1200" dirty="0"/>
+                        <a:rPr lang="en-US" sz="1200" dirty="0">
+                          <a:solidFill>
+                            <a:srgbClr val="000000"/>
+                          </a:solidFill>
+                          <a:latin typeface="Ubuntu"/>
+                        </a:rPr>
                         <a:t>Two </a:t>
                       </a:r>
                       <a:endParaRPr lang="en-US" sz="1200" dirty="0"/>
@@ -4746,10 +5031,15 @@
                         <a:buNone/>
                       </a:pPr>
                       <a:r>
-                        <a:rPr lang="en-US" sz="1200" dirty="0"/>
+                        <a:rPr lang="en-US" sz="1400" b="1" dirty="0">
+                          <a:solidFill>
+                            <a:srgbClr val="365F91"/>
+                          </a:solidFill>
+                          <a:latin typeface="Ubuntu"/>
+                        </a:rPr>
                         <a:t>Lists </a:t>
                       </a:r>
-                      <a:endParaRPr lang="en-US" sz="1200" dirty="0"/>
+                      <a:endParaRPr lang="en-US" sz="1400" dirty="0"/>
                     </a:p>
                   </a:txBody>
                   <a:tcPr>
@@ -4815,7 +5105,12 @@
                         <a:buNone/>
                       </a:pPr>
                       <a:r>
-                        <a:rPr lang="en-US" sz="1200" dirty="0"/>
+                        <a:rPr lang="en-US" sz="1200" dirty="0">
+                          <a:solidFill>
+                            <a:srgbClr val="000000"/>
+                          </a:solidFill>
+                          <a:latin typeface="Ubuntu"/>
+                        </a:rPr>
                         <a:t>1</a:t>
                       </a:r>
                       <a:endParaRPr lang="en-US" sz="1200" dirty="0"/>
@@ -4853,7 +5148,12 @@
                         <a:buNone/>
                       </a:pPr>
                       <a:r>
-                        <a:rPr lang="en-US" sz="1200" dirty="0"/>
+                        <a:rPr lang="en-US" sz="1200" dirty="0">
+                          <a:solidFill>
+                            <a:srgbClr val="000000"/>
+                          </a:solidFill>
+                          <a:latin typeface="Ubuntu"/>
+                        </a:rPr>
                         <a:t>Three </a:t>
                       </a:r>
                       <a:endParaRPr lang="en-US" sz="1200" dirty="0"/>
@@ -4893,7 +5193,12 @@
                         <a:buNone/>
                       </a:pPr>
                       <a:r>
-                        <a:rPr lang="en-US" sz="1200" dirty="0"/>
+                        <a:rPr lang="en-US" sz="1200" dirty="0">
+                          <a:solidFill>
+                            <a:srgbClr val="000000"/>
+                          </a:solidFill>
+                          <a:latin typeface="Ubuntu"/>
+                        </a:rPr>
                         <a:t>2</a:t>
                       </a:r>
                       <a:endParaRPr lang="en-US" sz="1200" dirty="0"/>
@@ -4931,7 +5236,12 @@
                         <a:buNone/>
                       </a:pPr>
                       <a:r>
-                        <a:rPr lang="en-US" sz="1200" dirty="0"/>
+                        <a:rPr lang="en-US" sz="1200" dirty="0">
+                          <a:solidFill>
+                            <a:srgbClr val="000000"/>
+                          </a:solidFill>
+                          <a:latin typeface="Ubuntu"/>
+                        </a:rPr>
                         <a:t>Four with a very long line to demonstrate that the hanging indent for the list is working correctly. </a:t>
                       </a:r>
                       <a:endParaRPr lang="en-US" sz="1200" dirty="0"/>
@@ -4971,7 +5281,12 @@
                         <a:buNone/>
                       </a:pPr>
                       <a:r>
-                        <a:rPr lang="en-US" sz="1200" dirty="0"/>
+                        <a:rPr lang="en-US" sz="1200" dirty="0">
+                          <a:solidFill>
+                            <a:srgbClr val="000000"/>
+                          </a:solidFill>
+                          <a:latin typeface="Ubuntu"/>
+                        </a:rPr>
                         <a:t>3</a:t>
                       </a:r>
                       <a:endParaRPr lang="en-US" sz="1200" dirty="0"/>
@@ -5009,7 +5324,12 @@
                         <a:buNone/>
                       </a:pPr>
                       <a:r>
-                        <a:rPr lang="en-US" sz="1200" dirty="0"/>
+                        <a:rPr lang="en-US" sz="1200" dirty="0">
+                          <a:solidFill>
+                            <a:srgbClr val="000000"/>
+                          </a:solidFill>
+                          <a:latin typeface="Ubuntu"/>
+                        </a:rPr>
                         <a:t>Five </a:t>
                       </a:r>
                       <a:endParaRPr lang="en-US" sz="1200" dirty="0"/>
@@ -5049,7 +5369,12 @@
                         <a:buNone/>
                       </a:pPr>
                       <a:r>
-                        <a:rPr lang="en-US" sz="1200" dirty="0"/>
+                        <a:rPr lang="en-US" sz="1200" dirty="0">
+                          <a:solidFill>
+                            <a:srgbClr val="000000"/>
+                          </a:solidFill>
+                          <a:latin typeface="Ubuntu"/>
+                        </a:rPr>
                         <a:t>2</a:t>
                       </a:r>
                       <a:endParaRPr lang="en-US" sz="1200" dirty="0"/>
@@ -5087,7 +5412,12 @@
                         <a:buNone/>
                       </a:pPr>
                       <a:r>
-                        <a:rPr lang="en-US" sz="1200" dirty="0"/>
+                        <a:rPr lang="en-US" sz="1200" dirty="0">
+                          <a:solidFill>
+                            <a:srgbClr val="000000"/>
+                          </a:solidFill>
+                          <a:latin typeface="Ubuntu"/>
+                        </a:rPr>
                         <a:t>Six </a:t>
                       </a:r>
                       <a:endParaRPr lang="en-US" sz="1200" dirty="0"/>
@@ -5127,7 +5457,12 @@
                         <a:buNone/>
                       </a:pPr>
                       <a:r>
-                        <a:rPr lang="en-US" sz="1200" dirty="0"/>
+                        <a:rPr lang="en-US" sz="1200" dirty="0">
+                          <a:solidFill>
+                            <a:srgbClr val="000000"/>
+                          </a:solidFill>
+                          <a:latin typeface="Ubuntu"/>
+                        </a:rPr>
                         <a:t>A Multi-level list with bullets: </a:t>
                       </a:r>
                       <a:endParaRPr lang="en-US" sz="1200" dirty="0"/>
@@ -5196,7 +5531,12 @@
                         <a:buNone/>
                       </a:pPr>
                       <a:r>
-                        <a:rPr lang="en-US" sz="1200" dirty="0"/>
+                        <a:rPr lang="en-US" sz="1200" dirty="0">
+                          <a:solidFill>
+                            <a:srgbClr val="000000"/>
+                          </a:solidFill>
+                          <a:latin typeface="Ubuntu"/>
+                        </a:rPr>
                         <a:t>One </a:t>
                       </a:r>
                       <a:endParaRPr lang="en-US" sz="1200" dirty="0"/>
@@ -5265,7 +5605,12 @@
                         <a:buNone/>
                       </a:pPr>
                       <a:r>
-                        <a:rPr lang="en-US" sz="1200" dirty="0"/>
+                        <a:rPr lang="en-US" sz="1200" dirty="0">
+                          <a:solidFill>
+                            <a:srgbClr val="000000"/>
+                          </a:solidFill>
+                          <a:latin typeface="Ubuntu"/>
+                        </a:rPr>
                         <a:t>Two </a:t>
                       </a:r>
                       <a:endParaRPr lang="en-US" sz="1200" dirty="0"/>
@@ -5334,7 +5679,12 @@
                         <a:buNone/>
                       </a:pPr>
                       <a:r>
-                        <a:rPr lang="en-US" sz="1200" dirty="0"/>
+                        <a:rPr lang="en-US" sz="1200" dirty="0">
+                          <a:solidFill>
+                            <a:srgbClr val="000000"/>
+                          </a:solidFill>
+                          <a:latin typeface="Ubuntu"/>
+                        </a:rPr>
                         <a:t>This bullet uses an image as the bullet item </a:t>
                       </a:r>
                       <a:endParaRPr lang="en-US" sz="1200" dirty="0"/>
@@ -5403,7 +5753,12 @@
                         <a:buNone/>
                       </a:pPr>
                       <a:r>
-                        <a:rPr lang="en-US" sz="1200" dirty="0"/>
+                        <a:rPr lang="en-US" sz="1200" dirty="0">
+                          <a:solidFill>
+                            <a:srgbClr val="000000"/>
+                          </a:solidFill>
+                          <a:latin typeface="Ubuntu"/>
+                        </a:rPr>
                         <a:t>Four </a:t>
                       </a:r>
                       <a:endParaRPr lang="en-US" sz="1200" dirty="0"/>
@@ -5472,7 +5827,12 @@
                         <a:buNone/>
                       </a:pPr>
                       <a:r>
-                        <a:rPr lang="en-US" sz="1200" dirty="0"/>
+                        <a:rPr lang="en-US" sz="1200" dirty="0">
+                          <a:solidFill>
+                            <a:srgbClr val="000000"/>
+                          </a:solidFill>
+                          <a:latin typeface="Ubuntu"/>
+                        </a:rPr>
                         <a:t>Five </a:t>
                       </a:r>
                       <a:endParaRPr lang="en-US" sz="1200" dirty="0"/>
@@ -5626,10 +5986,15 @@
                         <a:buNone/>
                       </a:pPr>
                       <a:r>
-                        <a:rPr lang="en-US" sz="1200" dirty="0"/>
+                        <a:rPr lang="en-US" sz="1400" b="1" dirty="0">
+                          <a:solidFill>
+                            <a:srgbClr val="365F91"/>
+                          </a:solidFill>
+                          <a:latin typeface="Ubuntu"/>
+                        </a:rPr>
                         <a:t>Lists </a:t>
                       </a:r>
-                      <a:endParaRPr lang="en-US" sz="1200" dirty="0"/>
+                      <a:endParaRPr lang="en-US" sz="1400" dirty="0"/>
                     </a:p>
                   </a:txBody>
                   <a:tcPr>
@@ -5695,10 +6060,15 @@
                         <a:buNone/>
                       </a:pPr>
                       <a:r>
-                        <a:rPr lang="en-US" sz="1200" dirty="0"/>
+                        <a:rPr lang="en-US" sz="1300" b="1" dirty="0">
+                          <a:solidFill>
+                            <a:srgbClr val="4F81BD"/>
+                          </a:solidFill>
+                          <a:latin typeface="Ubuntu"/>
+                        </a:rPr>
                         <a:t>Continued Lists </a:t>
                       </a:r>
-                      <a:endParaRPr lang="en-US" sz="1200" dirty="0"/>
+                      <a:endParaRPr lang="en-US" sz="1300" dirty="0"/>
                     </a:p>
                   </a:txBody>
                   <a:tcPr>
@@ -5764,7 +6134,12 @@
                         <a:buNone/>
                       </a:pPr>
                       <a:r>
-                        <a:rPr lang="en-US" sz="1200" dirty="0"/>
+                        <a:rPr lang="en-US" sz="1200" dirty="0">
+                          <a:solidFill>
+                            <a:srgbClr val="000000"/>
+                          </a:solidFill>
+                          <a:latin typeface="Ubuntu"/>
+                        </a:rPr>
                         <a:t>i</a:t>
                       </a:r>
                       <a:endParaRPr lang="en-US" sz="1200" dirty="0"/>
@@ -5802,7 +6177,12 @@
                         <a:buNone/>
                       </a:pPr>
                       <a:r>
-                        <a:rPr lang="en-US" sz="1200" dirty="0"/>
+                        <a:rPr lang="en-US" sz="1200" dirty="0">
+                          <a:solidFill>
+                            <a:srgbClr val="000000"/>
+                          </a:solidFill>
+                          <a:latin typeface="Ubuntu"/>
+                        </a:rPr>
                         <a:t>One </a:t>
                       </a:r>
                       <a:endParaRPr lang="en-US" sz="1200" dirty="0"/>
@@ -5842,7 +6222,12 @@
                         <a:buNone/>
                       </a:pPr>
                       <a:r>
-                        <a:rPr lang="en-US" sz="1200" dirty="0"/>
+                        <a:rPr lang="en-US" sz="1200" dirty="0">
+                          <a:solidFill>
+                            <a:srgbClr val="000000"/>
+                          </a:solidFill>
+                          <a:latin typeface="Ubuntu"/>
+                        </a:rPr>
                         <a:t>ii</a:t>
                       </a:r>
                       <a:endParaRPr lang="en-US" sz="1200" dirty="0"/>
@@ -5880,7 +6265,12 @@
                         <a:buNone/>
                       </a:pPr>
                       <a:r>
-                        <a:rPr lang="en-US" sz="1200" dirty="0"/>
+                        <a:rPr lang="en-US" sz="1200" dirty="0">
+                          <a:solidFill>
+                            <a:srgbClr val="000000"/>
+                          </a:solidFill>
+                          <a:latin typeface="Ubuntu"/>
+                        </a:rPr>
                         <a:t>Two </a:t>
                       </a:r>
                       <a:endParaRPr lang="en-US" sz="1200" dirty="0"/>
@@ -5920,7 +6310,12 @@
                         <a:buNone/>
                       </a:pPr>
                       <a:r>
-                        <a:rPr lang="en-US" sz="1200" dirty="0"/>
+                        <a:rPr lang="en-US" sz="1200" dirty="0">
+                          <a:solidFill>
+                            <a:srgbClr val="000000"/>
+                          </a:solidFill>
+                          <a:latin typeface="Ubuntu"/>
+                        </a:rPr>
                         <a:t>An interruption in our regularly scheduled listing, for this essential and very relevant public service announcement. </a:t>
                       </a:r>
                       <a:endParaRPr lang="en-US" sz="1200" dirty="0"/>
@@ -5989,7 +6384,12 @@
                         <a:buNone/>
                       </a:pPr>
                       <a:r>
-                        <a:rPr lang="en-US" sz="1200" dirty="0"/>
+                        <a:rPr lang="en-US" sz="1200" dirty="0">
+                          <a:solidFill>
+                            <a:srgbClr val="000000"/>
+                          </a:solidFill>
+                          <a:latin typeface="Ubuntu"/>
+                        </a:rPr>
                         <a:t>iii</a:t>
                       </a:r>
                       <a:endParaRPr lang="en-US" sz="1200" dirty="0"/>
@@ -6027,7 +6427,12 @@
                         <a:buNone/>
                       </a:pPr>
                       <a:r>
-                        <a:rPr lang="en-US" sz="1200" dirty="0"/>
+                        <a:rPr lang="en-US" sz="1200" dirty="0">
+                          <a:solidFill>
+                            <a:srgbClr val="000000"/>
+                          </a:solidFill>
+                          <a:latin typeface="Ubuntu"/>
+                        </a:rPr>
                         <a:t>We now resume our normal programming </a:t>
                       </a:r>
                       <a:endParaRPr lang="en-US" sz="1200" dirty="0"/>
@@ -6067,7 +6472,12 @@
                         <a:buNone/>
                       </a:pPr>
                       <a:r>
-                        <a:rPr lang="en-US" sz="1200" dirty="0"/>
+                        <a:rPr lang="en-US" sz="1200" dirty="0">
+                          <a:solidFill>
+                            <a:srgbClr val="000000"/>
+                          </a:solidFill>
+                          <a:latin typeface="Ubuntu"/>
+                        </a:rPr>
                         <a:t>iv</a:t>
                       </a:r>
                       <a:endParaRPr lang="en-US" sz="1200" dirty="0"/>
@@ -6105,7 +6515,12 @@
                         <a:buNone/>
                       </a:pPr>
                       <a:r>
-                        <a:rPr lang="en-US" sz="1200" dirty="0"/>
+                        <a:rPr lang="en-US" sz="1200" dirty="0">
+                          <a:solidFill>
+                            <a:srgbClr val="000000"/>
+                          </a:solidFill>
+                          <a:latin typeface="Ubuntu"/>
+                        </a:rPr>
                         <a:t>Four </a:t>
                       </a:r>
                       <a:endParaRPr lang="en-US" sz="1200" dirty="0"/>
@@ -6234,10 +6649,15 @@
                         <a:buNone/>
                       </a:pPr>
                       <a:r>
-                        <a:rPr lang="en-US" sz="1200" dirty="0"/>
+                        <a:rPr lang="en-US" sz="1400" b="1" dirty="0">
+                          <a:solidFill>
+                            <a:srgbClr val="365F91"/>
+                          </a:solidFill>
+                          <a:latin typeface="Ubuntu"/>
+                        </a:rPr>
                         <a:t>Charts</a:t>
                       </a:r>
-                      <a:endParaRPr lang="en-US" sz="1200" dirty="0"/>
+                      <a:endParaRPr lang="en-US" sz="1400" dirty="0"/>
                     </a:p>
                   </a:txBody>
                   <a:tcPr>
@@ -6511,7 +6931,11 @@
                         <a:buNone/>
                       </a:pPr>
                       <a:r>
-                        <a:rPr lang="en-US" sz="1200" dirty="0"/>
+                        <a:rPr lang="en-US" sz="1200" dirty="0">
+                          <a:solidFill>
+                            <a:srgbClr val="000000"/>
+                          </a:solidFill>
+                        </a:rPr>
                         <a:t>Series 1</a:t>
                       </a:r>
                       <a:endParaRPr lang="en-US" sz="1200" dirty="0"/>
@@ -6549,7 +6973,11 @@
                         <a:buNone/>
                       </a:pPr>
                       <a:r>
-                        <a:rPr lang="en-US" sz="1200" dirty="0"/>
+                        <a:rPr lang="en-US" sz="1200" dirty="0">
+                          <a:solidFill>
+                            <a:srgbClr val="000000"/>
+                          </a:solidFill>
+                        </a:rPr>
                         <a:t>Series 2</a:t>
                       </a:r>
                       <a:endParaRPr lang="en-US" sz="1200" dirty="0"/>
@@ -6587,7 +7015,11 @@
                         <a:buNone/>
                       </a:pPr>
                       <a:r>
-                        <a:rPr lang="en-US" sz="1200" dirty="0"/>
+                        <a:rPr lang="en-US" sz="1200" dirty="0">
+                          <a:solidFill>
+                            <a:srgbClr val="000000"/>
+                          </a:solidFill>
+                        </a:rPr>
                         <a:t>Series 3</a:t>
                       </a:r>
                       <a:endParaRPr lang="en-US" sz="1200" dirty="0"/>
@@ -6685,7 +7117,11 @@
                         <a:buNone/>
                       </a:pPr>
                       <a:r>
-                        <a:rPr lang="en-US" sz="1200" dirty="0"/>
+                        <a:rPr lang="en-US" sz="1200" dirty="0">
+                          <a:solidFill>
+                            <a:srgbClr val="000000"/>
+                          </a:solidFill>
+                        </a:rPr>
                         <a:t>Category 1</a:t>
                       </a:r>
                       <a:endParaRPr lang="en-US" sz="1200" dirty="0"/>
@@ -6723,7 +7159,11 @@
                         <a:buNone/>
                       </a:pPr>
                       <a:r>
-                        <a:rPr lang="en-US" sz="1200" dirty="0"/>
+                        <a:rPr lang="en-US" sz="1200" dirty="0">
+                          <a:solidFill>
+                            <a:srgbClr val="000000"/>
+                          </a:solidFill>
+                        </a:rPr>
                         <a:t>4.3</a:t>
                       </a:r>
                       <a:endParaRPr lang="en-US" sz="1200" dirty="0"/>
@@ -6761,7 +7201,11 @@
                         <a:buNone/>
                       </a:pPr>
                       <a:r>
-                        <a:rPr lang="en-US" sz="1200" dirty="0"/>
+                        <a:rPr lang="en-US" sz="1200" dirty="0">
+                          <a:solidFill>
+                            <a:srgbClr val="000000"/>
+                          </a:solidFill>
+                        </a:rPr>
                         <a:t>2.4</a:t>
                       </a:r>
                       <a:endParaRPr lang="en-US" sz="1200" dirty="0"/>
@@ -6799,7 +7243,11 @@
                         <a:buNone/>
                       </a:pPr>
                       <a:r>
-                        <a:rPr lang="en-US" sz="1200" dirty="0"/>
+                        <a:rPr lang="en-US" sz="1200" dirty="0">
+                          <a:solidFill>
+                            <a:srgbClr val="000000"/>
+                          </a:solidFill>
+                        </a:rPr>
                         <a:t>2</a:t>
                       </a:r>
                       <a:endParaRPr lang="en-US" sz="1200" dirty="0"/>
@@ -6902,7 +7350,11 @@
                         <a:buNone/>
                       </a:pPr>
                       <a:r>
-                        <a:rPr lang="en-US" sz="1200" dirty="0"/>
+                        <a:rPr lang="en-US" sz="1200" dirty="0">
+                          <a:solidFill>
+                            <a:srgbClr val="000000"/>
+                          </a:solidFill>
+                        </a:rPr>
                         <a:t>Category 2</a:t>
                       </a:r>
                       <a:endParaRPr lang="en-US" sz="1200" dirty="0"/>
@@ -6940,7 +7392,11 @@
                         <a:buNone/>
                       </a:pPr>
                       <a:r>
-                        <a:rPr lang="en-US" sz="1200" dirty="0"/>
+                        <a:rPr lang="en-US" sz="1200" dirty="0">
+                          <a:solidFill>
+                            <a:srgbClr val="000000"/>
+                          </a:solidFill>
+                        </a:rPr>
                         <a:t>2.5</a:t>
                       </a:r>
                       <a:endParaRPr lang="en-US" sz="1200" dirty="0"/>
@@ -6978,7 +7434,11 @@
                         <a:buNone/>
                       </a:pPr>
                       <a:r>
-                        <a:rPr lang="en-US" sz="1200" dirty="0"/>
+                        <a:rPr lang="en-US" sz="1200" dirty="0">
+                          <a:solidFill>
+                            <a:srgbClr val="000000"/>
+                          </a:solidFill>
+                        </a:rPr>
                         <a:t>4.4</a:t>
                       </a:r>
                       <a:endParaRPr lang="en-US" sz="1200" dirty="0"/>
@@ -7016,7 +7476,11 @@
                         <a:buNone/>
                       </a:pPr>
                       <a:r>
-                        <a:rPr lang="en-US" sz="1200" dirty="0"/>
+                        <a:rPr lang="en-US" sz="1200" dirty="0">
+                          <a:solidFill>
+                            <a:srgbClr val="000000"/>
+                          </a:solidFill>
+                        </a:rPr>
                         <a:t>2</a:t>
                       </a:r>
                       <a:endParaRPr lang="en-US" sz="1200" dirty="0"/>
@@ -7114,7 +7578,11 @@
                         <a:buNone/>
                       </a:pPr>
                       <a:r>
-                        <a:rPr lang="en-US" sz="1200" dirty="0"/>
+                        <a:rPr lang="en-US" sz="1200" dirty="0">
+                          <a:solidFill>
+                            <a:srgbClr val="000000"/>
+                          </a:solidFill>
+                        </a:rPr>
                         <a:t>Category 3</a:t>
                       </a:r>
                       <a:endParaRPr lang="en-US" sz="1200" dirty="0"/>
@@ -7152,7 +7620,11 @@
                         <a:buNone/>
                       </a:pPr>
                       <a:r>
-                        <a:rPr lang="en-US" sz="1200" dirty="0"/>
+                        <a:rPr lang="en-US" sz="1200" dirty="0">
+                          <a:solidFill>
+                            <a:srgbClr val="000000"/>
+                          </a:solidFill>
+                        </a:rPr>
                         <a:t>3.5</a:t>
                       </a:r>
                       <a:endParaRPr lang="en-US" sz="1200" dirty="0"/>
@@ -7190,7 +7662,11 @@
                         <a:buNone/>
                       </a:pPr>
                       <a:r>
-                        <a:rPr lang="en-US" sz="1200" dirty="0"/>
+                        <a:rPr lang="en-US" sz="1200" dirty="0">
+                          <a:solidFill>
+                            <a:srgbClr val="000000"/>
+                          </a:solidFill>
+                        </a:rPr>
                         <a:t>1.8</a:t>
                       </a:r>
                       <a:endParaRPr lang="en-US" sz="1200" dirty="0"/>
@@ -7228,7 +7704,11 @@
                         <a:buNone/>
                       </a:pPr>
                       <a:r>
-                        <a:rPr lang="en-US" sz="1200" dirty="0"/>
+                        <a:rPr lang="en-US" sz="1200" dirty="0">
+                          <a:solidFill>
+                            <a:srgbClr val="000000"/>
+                          </a:solidFill>
+                        </a:rPr>
                         <a:t>3</a:t>
                       </a:r>
                       <a:endParaRPr lang="en-US" sz="1200" dirty="0"/>
@@ -7326,7 +7806,11 @@
                         <a:buNone/>
                       </a:pPr>
                       <a:r>
-                        <a:rPr lang="en-US" sz="1200" dirty="0"/>
+                        <a:rPr lang="en-US" sz="1200" dirty="0">
+                          <a:solidFill>
+                            <a:srgbClr val="000000"/>
+                          </a:solidFill>
+                        </a:rPr>
                         <a:t>Category 4</a:t>
                       </a:r>
                       <a:endParaRPr lang="en-US" sz="1200" dirty="0"/>
@@ -7364,7 +7848,11 @@
                         <a:buNone/>
                       </a:pPr>
                       <a:r>
-                        <a:rPr lang="en-US" sz="1200" dirty="0"/>
+                        <a:rPr lang="en-US" sz="1200" dirty="0">
+                          <a:solidFill>
+                            <a:srgbClr val="000000"/>
+                          </a:solidFill>
+                        </a:rPr>
                         <a:t>4.5</a:t>
                       </a:r>
                       <a:endParaRPr lang="en-US" sz="1200" dirty="0"/>
@@ -7402,7 +7890,11 @@
                         <a:buNone/>
                       </a:pPr>
                       <a:r>
-                        <a:rPr lang="en-US" sz="1200" dirty="0"/>
+                        <a:rPr lang="en-US" sz="1200" dirty="0">
+                          <a:solidFill>
+                            <a:srgbClr val="000000"/>
+                          </a:solidFill>
+                        </a:rPr>
                         <a:t>2.8</a:t>
                       </a:r>
                       <a:endParaRPr lang="en-US" sz="1200" dirty="0"/>
@@ -7440,7 +7932,11 @@
                         <a:buNone/>
                       </a:pPr>
                       <a:r>
-                        <a:rPr lang="en-US" sz="1200" dirty="0"/>
+                        <a:rPr lang="en-US" sz="1200" dirty="0">
+                          <a:solidFill>
+                            <a:srgbClr val="000000"/>
+                          </a:solidFill>
+                        </a:rPr>
                         <a:t>5</a:t>
                       </a:r>
                       <a:endParaRPr lang="en-US" sz="1200" dirty="0"/>
@@ -7565,10 +8061,15 @@
                         <a:buNone/>
                       </a:pPr>
                       <a:r>
-                        <a:rPr lang="en-US" sz="1200" dirty="0"/>
+                        <a:rPr lang="en-US" sz="2600" dirty="0">
+                          <a:solidFill>
+                            <a:srgbClr val="17365D"/>
+                          </a:solidFill>
+                          <a:latin typeface="Ubuntu"/>
+                        </a:rPr>
                         <a:t>Demonstration of DOCX support in calibre </a:t>
                       </a:r>
-                      <a:endParaRPr lang="en-US" sz="1200" dirty="0"/>
+                      <a:endParaRPr lang="en-US" sz="2600" dirty="0"/>
                     </a:p>
                   </a:txBody>
                   <a:tcPr>
@@ -7663,7 +8164,12 @@
                         <a:buNone/>
                       </a:pPr>
                       <a:r>
-                        <a:rPr lang="en-US" sz="1200" dirty="0"/>
+                        <a:rPr lang="en-US" sz="1200" dirty="0">
+                          <a:solidFill>
+                            <a:srgbClr val="000000"/>
+                          </a:solidFill>
+                          <a:latin typeface="Ubuntu"/>
+                        </a:rPr>
                         <a:t>Six </a:t>
                       </a:r>
                       <a:endParaRPr lang="en-US" sz="1200" dirty="0"/>
@@ -7732,7 +8238,12 @@
                         <a:buNone/>
                       </a:pPr>
                       <a:r>
-                        <a:rPr lang="en-US" sz="1200" dirty="0"/>
+                        <a:rPr lang="en-US" sz="1200" dirty="0">
+                          <a:solidFill>
+                            <a:srgbClr val="000000"/>
+                          </a:solidFill>
+                          <a:latin typeface="Ubuntu"/>
+                        </a:rPr>
                         <a:t>One </a:t>
                       </a:r>
                       <a:endParaRPr lang="en-US" sz="1200" dirty="0"/>
@@ -7801,7 +8312,12 @@
                         <a:buNone/>
                       </a:pPr>
                       <a:r>
-                        <a:rPr lang="en-US" sz="1200" dirty="0"/>
+                        <a:rPr lang="en-US" sz="1200" dirty="0">
+                          <a:solidFill>
+                            <a:srgbClr val="000000"/>
+                          </a:solidFill>
+                          <a:latin typeface="Ubuntu"/>
+                        </a:rPr>
                         <a:t>Two </a:t>
                       </a:r>
                       <a:endParaRPr lang="en-US" sz="1200" dirty="0"/>
@@ -7870,7 +8386,12 @@
                         <a:buNone/>
                       </a:pPr>
                       <a:r>
-                        <a:rPr lang="en-US" sz="1200" dirty="0"/>
+                        <a:rPr lang="en-US" sz="1200" dirty="0">
+                          <a:solidFill>
+                            <a:srgbClr val="000000"/>
+                          </a:solidFill>
+                          <a:latin typeface="Ubuntu"/>
+                        </a:rPr>
                         <a:t>We now resume our normal programming </a:t>
                       </a:r>
                       <a:endParaRPr lang="en-US" sz="1200" dirty="0"/>
@@ -7939,7 +8460,12 @@
                         <a:buNone/>
                       </a:pPr>
                       <a:r>
-                        <a:rPr lang="en-US" sz="1200" dirty="0"/>
+                        <a:rPr lang="en-US" sz="1200" dirty="0">
+                          <a:solidFill>
+                            <a:srgbClr val="000000"/>
+                          </a:solidFill>
+                          <a:latin typeface="Ubuntu"/>
+                        </a:rPr>
                         <a:t>Four </a:t>
                       </a:r>
                       <a:endParaRPr lang="en-US" sz="1200" dirty="0"/>
@@ -8063,10 +8589,15 @@
                         <a:buNone/>
                       </a:pPr>
                       <a:r>
-                        <a:rPr lang="en-US" sz="1200" dirty="0"/>
+                        <a:rPr lang="en-US" sz="1400" b="1" dirty="0">
+                          <a:solidFill>
+                            <a:srgbClr val="365F91"/>
+                          </a:solidFill>
+                          <a:latin typeface="Ubuntu"/>
+                        </a:rPr>
                         <a:t>Text Formatting </a:t>
                       </a:r>
-                      <a:endParaRPr lang="en-US" sz="1200" dirty="0"/>
+                      <a:endParaRPr lang="en-US" sz="1400" dirty="0"/>
                     </a:p>
                   </a:txBody>
                   <a:tcPr>
@@ -8103,10 +8634,15 @@
                         <a:buNone/>
                       </a:pPr>
                       <a:r>
-                        <a:rPr lang="en-US" sz="1200" dirty="0"/>
+                        <a:rPr lang="en-US" sz="1300" b="1" dirty="0">
+                          <a:solidFill>
+                            <a:srgbClr val="4F81BD"/>
+                          </a:solidFill>
+                          <a:latin typeface="Ubuntu"/>
+                        </a:rPr>
                         <a:t>Inline formatting </a:t>
                       </a:r>
-                      <a:endParaRPr lang="en-US" sz="1200" dirty="0"/>
+                      <a:endParaRPr lang="en-US" sz="1300" dirty="0"/>
                     </a:p>
                   </a:txBody>
                   <a:tcPr>
@@ -8143,7 +8679,12 @@
                         <a:buNone/>
                       </a:pPr>
                       <a:r>
-                        <a:rPr lang="en-US" sz="1200" dirty="0"/>
+                        <a:rPr lang="en-US" sz="1200" dirty="0">
+                          <a:solidFill>
+                            <a:srgbClr val="000000"/>
+                          </a:solidFill>
+                          <a:latin typeface="Ubuntu"/>
+                        </a:rPr>
                         <a:t>Here, we demonstrate various types of inline text formatting and the use of embedded fonts. </a:t>
                       </a:r>
                       <a:endParaRPr lang="en-US" sz="1200" dirty="0"/>
@@ -8381,7 +8922,12 @@
                         <a:buNone/>
                       </a:pPr>
                       <a:r>
-                        <a:rPr lang="en-US" sz="1200" dirty="0"/>
+                        <a:rPr lang="en-US" sz="1200" dirty="0">
+                          <a:solidFill>
+                            <a:srgbClr val="FFFFFF"/>
+                          </a:solidFill>
+                          <a:latin typeface="Ubuntu"/>
+                        </a:rPr>
                         <a:t>inverse video</a:t>
                       </a:r>
                       <a:endParaRPr lang="en-US" sz="1200" dirty="0"/>
@@ -8421,7 +8967,12 @@
                         <a:buNone/>
                       </a:pPr>
                       <a:r>
-                        <a:rPr lang="en-US" sz="1200" dirty="0"/>
+                        <a:rPr lang="en-US" sz="1200" dirty="0">
+                          <a:solidFill>
+                            <a:srgbClr val="000000"/>
+                          </a:solidFill>
+                          <a:latin typeface="Ubuntu"/>
+                        </a:rPr>
                         <a:t>.</a:t>
                       </a:r>
                       <a:endParaRPr lang="en-US" sz="1200" dirty="0"/>
@@ -8461,7 +9012,12 @@
                         <a:buNone/>
                       </a:pPr>
                       <a:r>
-                        <a:rPr lang="en-US" sz="1200" dirty="0"/>
+                        <a:rPr lang="en-US" sz="1200" dirty="0">
+                          <a:solidFill>
+                            <a:srgbClr val="000000"/>
+                          </a:solidFill>
+                          <a:latin typeface="Ubuntu"/>
+                        </a:rPr>
                         <a:t>A paragraph with styled text: </a:t>
                       </a:r>
                       <a:r>
@@ -8474,7 +9030,12 @@
                         <a:t>subtle emphasis  </a:t>
                       </a:r>
                       <a:r>
-                        <a:rPr lang="en-US" sz="1200" dirty="0"/>
+                        <a:rPr lang="en-US" sz="1200" dirty="0">
+                          <a:solidFill>
+                            <a:srgbClr val="000000"/>
+                          </a:solidFill>
+                          <a:latin typeface="Ubuntu"/>
+                        </a:rPr>
                         <a:t>followed by </a:t>
                       </a:r>
                       <a:r>
@@ -8487,7 +9048,12 @@
                         <a:t>strong text </a:t>
                       </a:r>
                       <a:r>
-                        <a:rPr lang="en-US" sz="1200" dirty="0"/>
+                        <a:rPr lang="en-US" sz="1200" dirty="0">
+                          <a:solidFill>
+                            <a:srgbClr val="000000"/>
+                          </a:solidFill>
+                          <a:latin typeface="Ubuntu"/>
+                        </a:rPr>
                         <a:t>and </a:t>
                       </a:r>
                       <a:r>
@@ -8500,7 +9066,12 @@
                         <a:t>intense emphasis</a:t>
                       </a:r>
                       <a:r>
-                        <a:rPr lang="en-US" sz="1200" dirty="0"/>
+                        <a:rPr lang="en-US" sz="1200" dirty="0">
+                          <a:solidFill>
+                            <a:srgbClr val="000000"/>
+                          </a:solidFill>
+                          <a:latin typeface="Ubuntu"/>
+                        </a:rPr>
                         <a:t>. This paragraph uses document wide styles for styling rather than inline text properties as demonstrated in the previous paragraph — calibre can handle both with equal ease. </a:t>
                       </a:r>
                       <a:endParaRPr lang="en-US" sz="1200" dirty="0"/>
@@ -8540,10 +9111,15 @@
                         <a:buNone/>
                       </a:pPr>
                       <a:r>
-                        <a:rPr lang="en-US" sz="1200" dirty="0"/>
+                        <a:rPr lang="en-US" sz="1300" b="1" dirty="0">
+                          <a:solidFill>
+                            <a:srgbClr val="4F81BD"/>
+                          </a:solidFill>
+                          <a:latin typeface="Ubuntu"/>
+                        </a:rPr>
                         <a:t>Fun with fonts </a:t>
                       </a:r>
-                      <a:endParaRPr lang="en-US" sz="1200" dirty="0"/>
+                      <a:endParaRPr lang="en-US" sz="1300" dirty="0"/>
                     </a:p>
                   </a:txBody>
                   <a:tcPr>
@@ -8580,7 +9156,12 @@
                         <a:buNone/>
                       </a:pPr>
                       <a:r>
-                        <a:rPr lang="en-US" sz="1200" dirty="0"/>
+                        <a:rPr lang="en-US" sz="1200" dirty="0">
+                          <a:solidFill>
+                            <a:srgbClr val="000000"/>
+                          </a:solidFill>
+                          <a:latin typeface="Ubuntu"/>
+                        </a:rPr>
                         <a:t>This document has embedded the Ubuntu font family. The body text is in the Ubuntu typeface, here is </a:t>
                       </a:r>
                       <a:r>
@@ -8593,7 +9174,12 @@
                         <a:t>some text in the Ubuntu Mono typeface, notice how every letter has the same width, even i and m</a:t>
                       </a:r>
                       <a:r>
-                        <a:rPr lang="en-US" sz="1200" dirty="0"/>
+                        <a:rPr lang="en-US" sz="1200" dirty="0">
+                          <a:solidFill>
+                            <a:srgbClr val="000000"/>
+                          </a:solidFill>
+                          <a:latin typeface="Ubuntu"/>
+                        </a:rPr>
                         <a:t>. Every embedded font will automatically be embedded in the output ebook during conversion.  </a:t>
                       </a:r>
                       <a:endParaRPr lang="en-US" sz="1200" dirty="0"/>
@@ -8633,10 +9219,15 @@
                         <a:buNone/>
                       </a:pPr>
                       <a:r>
-                        <a:rPr lang="en-US" sz="1200" dirty="0"/>
+                        <a:rPr lang="en-US" sz="1300" b="1" dirty="0">
+                          <a:solidFill>
+                            <a:srgbClr val="4F81BD"/>
+                          </a:solidFill>
+                          <a:latin typeface="Ubuntu"/>
+                        </a:rPr>
                         <a:t>Paragraph level formatting </a:t>
                       </a:r>
-                      <a:endParaRPr lang="en-US" sz="1200" dirty="0"/>
+                      <a:endParaRPr lang="en-US" sz="1300" dirty="0"/>
                     </a:p>
                   </a:txBody>
                   <a:tcPr>
@@ -8673,7 +9264,12 @@
                         <a:buNone/>
                       </a:pPr>
                       <a:r>
-                        <a:rPr lang="en-US" sz="1200" dirty="0"/>
+                        <a:rPr lang="en-US" sz="1200" dirty="0">
+                          <a:solidFill>
+                            <a:srgbClr val="000000"/>
+                          </a:solidFill>
+                          <a:latin typeface="Ubuntu"/>
+                        </a:rPr>
                         <a:t>You can do crazy things with paragraphs, if the urge strikes you. For instance this paragraph is right aligned and has a right border. It has also been given a light gray background. </a:t>
                       </a:r>
                       <a:endParaRPr lang="en-US" sz="1200" dirty="0"/>
@@ -8797,10 +9393,15 @@
                         <a:buNone/>
                       </a:pPr>
                       <a:r>
-                        <a:rPr lang="en-US" sz="1200" dirty="0"/>
+                        <a:rPr lang="en-US" sz="1400" b="1" dirty="0">
+                          <a:solidFill>
+                            <a:srgbClr val="365F91"/>
+                          </a:solidFill>
+                          <a:latin typeface="Ubuntu"/>
+                        </a:rPr>
                         <a:t>Text Formatting </a:t>
                       </a:r>
-                      <a:endParaRPr lang="en-US" sz="1200" dirty="0"/>
+                      <a:endParaRPr lang="en-US" sz="1400" dirty="0"/>
                     </a:p>
                   </a:txBody>
                   <a:tcPr>
@@ -8837,14 +9438,24 @@
                         <a:buNone/>
                       </a:pPr>
                       <a:r>
-                        <a:rPr lang="en-US" sz="1200" dirty="0"/>
+                        <a:rPr lang="en-US" sz="1200" dirty="0">
+                          <a:solidFill>
+                            <a:srgbClr val="000000"/>
+                          </a:solidFill>
+                          <a:latin typeface="Ubuntu"/>
+                        </a:rPr>
                         <a:t>For the lovers of poetry amongst you, paragraphs with hanging indents, like this often</a:t>
                       </a:r>
                       <a:br>
                         <a:rPr lang="en-US" dirty="0"/>
                       </a:br>
                       <a:r>
-                        <a:rPr lang="en-US" sz="1200" dirty="0"/>
+                        <a:rPr lang="en-US" sz="1200" dirty="0">
+                          <a:solidFill>
+                            <a:srgbClr val="000000"/>
+                          </a:solidFill>
+                          <a:latin typeface="Ubuntu"/>
+                        </a:rPr>
                         <a:t>come in handy. You can use hanging indents to ensure that a line of poetry retains its individual identity as a line even when the screen is  too narrow to display it as a single line. Not only does this paragraph have a hanging indent, it is also has an extra top margin, setting it apart from the preceding paragraph. </a:t>
                       </a:r>
                       <a:endParaRPr lang="en-US" sz="1200" dirty="0"/>
@@ -8973,10 +9584,15 @@
                         <a:buNone/>
                       </a:pPr>
                       <a:r>
-                        <a:rPr lang="en-US" sz="1200" dirty="0"/>
+                        <a:rPr lang="en-US" sz="1400" b="1" dirty="0">
+                          <a:solidFill>
+                            <a:srgbClr val="365F91"/>
+                          </a:solidFill>
+                          <a:latin typeface="Ubuntu"/>
+                        </a:rPr>
                         <a:t>Tables </a:t>
                       </a:r>
-                      <a:endParaRPr lang="en-US" sz="1200" dirty="0"/>
+                      <a:endParaRPr lang="en-US" sz="1400" dirty="0"/>
                     </a:p>
                   </a:txBody>
                   <a:tcPr>
@@ -9158,7 +9774,12 @@
                         <a:buNone/>
                       </a:pPr>
                       <a:r>
-                        <a:rPr lang="en-US" sz="1200" dirty="0"/>
+                        <a:rPr lang="en-US" sz="1200" b="1" dirty="0">
+                          <a:solidFill>
+                            <a:srgbClr val="FFFFFF"/>
+                          </a:solidFill>
+                          <a:latin typeface="Ubuntu"/>
+                        </a:rPr>
                         <a:t>ITEM </a:t>
                       </a:r>
                       <a:endParaRPr lang="en-US" sz="1200" dirty="0"/>
@@ -9196,7 +9817,12 @@
                         <a:buNone/>
                       </a:pPr>
                       <a:r>
-                        <a:rPr lang="en-US" sz="1200" dirty="0"/>
+                        <a:rPr lang="en-US" sz="1200" b="1" dirty="0">
+                          <a:solidFill>
+                            <a:srgbClr val="FFFFFF"/>
+                          </a:solidFill>
+                          <a:latin typeface="Ubuntu"/>
+                        </a:rPr>
                         <a:t>NEEDED </a:t>
                       </a:r>
                       <a:endParaRPr lang="en-US" sz="1200" dirty="0"/>
@@ -9352,7 +9978,12 @@
                         <a:buNone/>
                       </a:pPr>
                       <a:r>
-                        <a:rPr lang="en-US" sz="1200" dirty="0"/>
+                        <a:rPr lang="en-US" sz="1200" dirty="0">
+                          <a:solidFill>
+                            <a:srgbClr val="000000"/>
+                          </a:solidFill>
+                          <a:latin typeface="Ubuntu"/>
+                        </a:rPr>
                         <a:t>Books </a:t>
                       </a:r>
                       <a:endParaRPr lang="en-US" sz="1200" dirty="0"/>
@@ -9390,7 +10021,12 @@
                         <a:buNone/>
                       </a:pPr>
                       <a:r>
-                        <a:rPr lang="en-US" sz="1200" dirty="0"/>
+                        <a:rPr lang="en-US" sz="1200" dirty="0">
+                          <a:solidFill>
+                            <a:srgbClr val="000000"/>
+                          </a:solidFill>
+                          <a:latin typeface="Ubuntu"/>
+                        </a:rPr>
                         <a:t>1 </a:t>
                       </a:r>
                       <a:endParaRPr lang="en-US" sz="1200" dirty="0"/>
@@ -9546,7 +10182,12 @@
                         <a:buNone/>
                       </a:pPr>
                       <a:r>
-                        <a:rPr lang="en-US" sz="1200" dirty="0"/>
+                        <a:rPr lang="en-US" sz="1200" dirty="0">
+                          <a:solidFill>
+                            <a:srgbClr val="000000"/>
+                          </a:solidFill>
+                          <a:latin typeface="Ubuntu"/>
+                        </a:rPr>
                         <a:t>Pens </a:t>
                       </a:r>
                       <a:endParaRPr lang="en-US" sz="1200" dirty="0"/>
@@ -9584,7 +10225,12 @@
                         <a:buNone/>
                       </a:pPr>
                       <a:r>
-                        <a:rPr lang="en-US" sz="1200" dirty="0"/>
+                        <a:rPr lang="en-US" sz="1200" dirty="0">
+                          <a:solidFill>
+                            <a:srgbClr val="000000"/>
+                          </a:solidFill>
+                          <a:latin typeface="Ubuntu"/>
+                        </a:rPr>
                         <a:t>3 </a:t>
                       </a:r>
                       <a:endParaRPr lang="en-US" sz="1200" dirty="0"/>
@@ -9740,7 +10386,12 @@
                         <a:buNone/>
                       </a:pPr>
                       <a:r>
-                        <a:rPr lang="en-US" sz="1200" dirty="0"/>
+                        <a:rPr lang="en-US" sz="1200" dirty="0">
+                          <a:solidFill>
+                            <a:srgbClr val="000000"/>
+                          </a:solidFill>
+                          <a:latin typeface="Ubuntu"/>
+                        </a:rPr>
                         <a:t>Pencils </a:t>
                       </a:r>
                       <a:endParaRPr lang="en-US" sz="1200" dirty="0"/>
@@ -9778,7 +10429,12 @@
                         <a:buNone/>
                       </a:pPr>
                       <a:r>
-                        <a:rPr lang="en-US" sz="1200" dirty="0"/>
+                        <a:rPr lang="en-US" sz="1200" dirty="0">
+                          <a:solidFill>
+                            <a:srgbClr val="000000"/>
+                          </a:solidFill>
+                          <a:latin typeface="Ubuntu"/>
+                        </a:rPr>
                         <a:t>2 </a:t>
                       </a:r>
                       <a:endParaRPr lang="en-US" sz="1200" dirty="0"/>
@@ -9934,7 +10590,12 @@
                         <a:buNone/>
                       </a:pPr>
                       <a:r>
-                        <a:rPr lang="en-US" sz="1200" dirty="0"/>
+                        <a:rPr lang="en-US" sz="1200" dirty="0">
+                          <a:solidFill>
+                            <a:srgbClr val="000000"/>
+                          </a:solidFill>
+                          <a:latin typeface="Ubuntu"/>
+                        </a:rPr>
                         <a:t>Highlighter </a:t>
                       </a:r>
                       <a:endParaRPr lang="en-US" sz="1200" dirty="0"/>
@@ -9972,7 +10633,12 @@
                         <a:buNone/>
                       </a:pPr>
                       <a:r>
-                        <a:rPr lang="en-US" sz="1200" dirty="0"/>
+                        <a:rPr lang="en-US" sz="1200" dirty="0">
+                          <a:solidFill>
+                            <a:srgbClr val="000000"/>
+                          </a:solidFill>
+                          <a:latin typeface="Ubuntu"/>
+                        </a:rPr>
                         <a:t>2 colors </a:t>
                       </a:r>
                       <a:endParaRPr lang="en-US" sz="1200" dirty="0"/>
@@ -10128,7 +10794,12 @@
                         <a:buNone/>
                       </a:pPr>
                       <a:r>
-                        <a:rPr lang="en-US" sz="1200" dirty="0"/>
+                        <a:rPr lang="en-US" sz="1200" dirty="0">
+                          <a:solidFill>
+                            <a:srgbClr val="000000"/>
+                          </a:solidFill>
+                          <a:latin typeface="Ubuntu"/>
+                        </a:rPr>
                         <a:t>Scissors </a:t>
                       </a:r>
                       <a:endParaRPr lang="en-US" sz="1200" dirty="0"/>
@@ -10166,7 +10837,12 @@
                         <a:buNone/>
                       </a:pPr>
                       <a:r>
-                        <a:rPr lang="en-US" sz="1200" dirty="0"/>
+                        <a:rPr lang="en-US" sz="1200" dirty="0">
+                          <a:solidFill>
+                            <a:srgbClr val="000000"/>
+                          </a:solidFill>
+                          <a:latin typeface="Ubuntu"/>
+                        </a:rPr>
                         <a:t>1 pair </a:t>
                       </a:r>
                       <a:endParaRPr lang="en-US" sz="1200" dirty="0"/>
@@ -10322,7 +10998,12 @@
                         <a:buNone/>
                       </a:pPr>
                       <a:r>
-                        <a:rPr lang="en-US" sz="1200" dirty="0"/>
+                        <a:rPr lang="en-US" sz="1200" dirty="0">
+                          <a:solidFill>
+                            <a:srgbClr val="000000"/>
+                          </a:solidFill>
+                          <a:latin typeface="Ubuntu"/>
+                        </a:rPr>
                         <a:t>Tables in Word can vary from the extremely simple to the extremely complex. calibre tries to do its best when converting tables. While you may run into trouble with the occasional table, the vast majority of common cases should be converted very well, as demonstrated in this section. Note that for optimum results, when creating tables in Word, you should set their widths using percentages, rather than absolute units.  To the left of this paragraph is a floating two column table with a nice green border and header row. </a:t>
                       </a:r>
                       <a:endParaRPr lang="en-US" sz="1200" dirty="0"/>
@@ -10507,7 +11188,12 @@
                         <a:buNone/>
                       </a:pPr>
                       <a:r>
-                        <a:rPr lang="en-US" sz="1200" dirty="0"/>
+                        <a:rPr lang="en-US" sz="1200" dirty="0">
+                          <a:solidFill>
+                            <a:srgbClr val="000000"/>
+                          </a:solidFill>
+                          <a:latin typeface="Ubuntu"/>
+                        </a:rPr>
                         <a:t>Now let’s look at a fancier table—one with alternating row colors and partial borders. This table is stretched out to take 100% of the available width. </a:t>
                       </a:r>
                       <a:endParaRPr lang="en-US" sz="1200" dirty="0"/>
@@ -10692,7 +11378,12 @@
                         <a:buNone/>
                       </a:pPr>
                       <a:r>
-                        <a:rPr lang="en-US" sz="1200" dirty="0"/>
+                        <a:rPr lang="en-US" sz="1200" dirty="0">
+                          <a:solidFill>
+                            <a:srgbClr val="000000"/>
+                          </a:solidFill>
+                          <a:latin typeface="Ubuntu"/>
+                        </a:rPr>
                         <a:t>City or Town </a:t>
                       </a:r>
                       <a:endParaRPr lang="en-US" sz="1200" dirty="0"/>
@@ -10730,7 +11421,12 @@
                         <a:buNone/>
                       </a:pPr>
                       <a:r>
-                        <a:rPr lang="en-US" sz="1200" dirty="0"/>
+                        <a:rPr lang="en-US" sz="1200" dirty="0">
+                          <a:solidFill>
+                            <a:srgbClr val="000000"/>
+                          </a:solidFill>
+                          <a:latin typeface="Ubuntu"/>
+                        </a:rPr>
                         <a:t>Point A </a:t>
                       </a:r>
                       <a:endParaRPr lang="en-US" sz="1200" dirty="0"/>
@@ -10768,7 +11464,12 @@
                         <a:buNone/>
                       </a:pPr>
                       <a:r>
-                        <a:rPr lang="en-US" sz="1200" dirty="0"/>
+                        <a:rPr lang="en-US" sz="1200" dirty="0">
+                          <a:solidFill>
+                            <a:srgbClr val="000000"/>
+                          </a:solidFill>
+                          <a:latin typeface="Ubuntu"/>
+                        </a:rPr>
                         <a:t>Point B </a:t>
                       </a:r>
                       <a:endParaRPr lang="en-US" sz="1200" dirty="0"/>
@@ -10806,7 +11507,12 @@
                         <a:buNone/>
                       </a:pPr>
                       <a:r>
-                        <a:rPr lang="en-US" sz="1200" dirty="0"/>
+                        <a:rPr lang="en-US" sz="1200" dirty="0">
+                          <a:solidFill>
+                            <a:srgbClr val="000000"/>
+                          </a:solidFill>
+                          <a:latin typeface="Ubuntu"/>
+                        </a:rPr>
                         <a:t>Point C </a:t>
                       </a:r>
                       <a:endParaRPr lang="en-US" sz="1200" dirty="0"/>
@@ -10844,7 +11550,12 @@
                         <a:buNone/>
                       </a:pPr>
                       <a:r>
-                        <a:rPr lang="en-US" sz="1200" dirty="0"/>
+                        <a:rPr lang="en-US" sz="1200" dirty="0">
+                          <a:solidFill>
+                            <a:srgbClr val="000000"/>
+                          </a:solidFill>
+                          <a:latin typeface="Ubuntu"/>
+                        </a:rPr>
                         <a:t>Point D </a:t>
                       </a:r>
                       <a:endParaRPr lang="en-US" sz="1200" dirty="0"/>
@@ -10882,7 +11593,12 @@
                         <a:buNone/>
                       </a:pPr>
                       <a:r>
-                        <a:rPr lang="en-US" sz="1200" dirty="0"/>
+                        <a:rPr lang="en-US" sz="1200" dirty="0">
+                          <a:solidFill>
+                            <a:srgbClr val="000000"/>
+                          </a:solidFill>
+                          <a:latin typeface="Ubuntu"/>
+                        </a:rPr>
                         <a:t>Point E </a:t>
                       </a:r>
                       <a:endParaRPr lang="en-US" sz="1200" dirty="0"/>
@@ -10922,7 +11638,12 @@
                         <a:buNone/>
                       </a:pPr>
                       <a:r>
-                        <a:rPr lang="en-US" sz="1200" dirty="0"/>
+                        <a:rPr lang="en-US" sz="1200" dirty="0">
+                          <a:solidFill>
+                            <a:srgbClr val="000000"/>
+                          </a:solidFill>
+                          <a:latin typeface="Ubuntu"/>
+                        </a:rPr>
                         <a:t>Point A </a:t>
                       </a:r>
                       <a:endParaRPr lang="en-US" sz="1200" dirty="0"/>
@@ -10960,7 +11681,12 @@
                         <a:buNone/>
                       </a:pPr>
                       <a:r>
-                        <a:rPr lang="en-US" sz="1200" dirty="0"/>
+                        <a:rPr lang="en-US" sz="1200" dirty="0">
+                          <a:solidFill>
+                            <a:srgbClr val="000000"/>
+                          </a:solidFill>
+                          <a:latin typeface="Ubuntu"/>
+                        </a:rPr>
                         <a:t>— </a:t>
                       </a:r>
                       <a:endParaRPr lang="en-US" sz="1200" dirty="0"/>
@@ -11225,10 +11951,15 @@
                         <a:buNone/>
                       </a:pPr>
                       <a:r>
-                        <a:rPr lang="en-US" sz="1200" dirty="0"/>
+                        <a:rPr lang="en-US" sz="1400" b="1" dirty="0">
+                          <a:solidFill>
+                            <a:srgbClr val="365F91"/>
+                          </a:solidFill>
+                          <a:latin typeface="Ubuntu"/>
+                        </a:rPr>
                         <a:t>Tables </a:t>
                       </a:r>
-                      <a:endParaRPr lang="en-US" sz="1200" dirty="0"/>
+                      <a:endParaRPr lang="en-US" sz="1400" dirty="0"/>
                     </a:p>
                   </a:txBody>
                   <a:tcPr>
@@ -11410,7 +12141,12 @@
                         <a:buNone/>
                       </a:pPr>
                       <a:r>
-                        <a:rPr lang="en-US" sz="1200" dirty="0"/>
+                        <a:rPr lang="en-US" sz="1200" dirty="0">
+                          <a:solidFill>
+                            <a:srgbClr val="000000"/>
+                          </a:solidFill>
+                          <a:latin typeface="Ubuntu"/>
+                        </a:rPr>
                         <a:t>Point B </a:t>
                       </a:r>
                       <a:endParaRPr lang="en-US" sz="1200" dirty="0"/>
@@ -11448,7 +12184,12 @@
                         <a:buNone/>
                       </a:pPr>
                       <a:r>
-                        <a:rPr lang="en-US" sz="1200" dirty="0"/>
+                        <a:rPr lang="en-US" sz="1200" dirty="0">
+                          <a:solidFill>
+                            <a:srgbClr val="000000"/>
+                          </a:solidFill>
+                          <a:latin typeface="Ubuntu"/>
+                        </a:rPr>
                         <a:t>87 </a:t>
                       </a:r>
                       <a:endParaRPr lang="en-US" sz="1200" dirty="0"/>
@@ -11486,7 +12227,12 @@
                         <a:buNone/>
                       </a:pPr>
                       <a:r>
-                        <a:rPr lang="en-US" sz="1200" dirty="0"/>
+                        <a:rPr lang="en-US" sz="1200" dirty="0">
+                          <a:solidFill>
+                            <a:srgbClr val="000000"/>
+                          </a:solidFill>
+                          <a:latin typeface="Ubuntu"/>
+                        </a:rPr>
                         <a:t>— </a:t>
                       </a:r>
                       <a:endParaRPr lang="en-US" sz="1200" dirty="0"/>
@@ -11628,7 +12374,12 @@
                         <a:buNone/>
                       </a:pPr>
                       <a:r>
-                        <a:rPr lang="en-US" sz="1200" dirty="0"/>
+                        <a:rPr lang="en-US" sz="1200" dirty="0">
+                          <a:solidFill>
+                            <a:srgbClr val="000000"/>
+                          </a:solidFill>
+                          <a:latin typeface="Ubuntu"/>
+                        </a:rPr>
                         <a:t>Point C </a:t>
                       </a:r>
                       <a:endParaRPr lang="en-US" sz="1200" dirty="0"/>
@@ -11666,7 +12417,12 @@
                         <a:buNone/>
                       </a:pPr>
                       <a:r>
-                        <a:rPr lang="en-US" sz="1200" dirty="0"/>
+                        <a:rPr lang="en-US" sz="1200" dirty="0">
+                          <a:solidFill>
+                            <a:srgbClr val="000000"/>
+                          </a:solidFill>
+                          <a:latin typeface="Ubuntu"/>
+                        </a:rPr>
                         <a:t>64 </a:t>
                       </a:r>
                       <a:endParaRPr lang="en-US" sz="1200" dirty="0"/>
@@ -11704,7 +12460,12 @@
                         <a:buNone/>
                       </a:pPr>
                       <a:r>
-                        <a:rPr lang="en-US" sz="1200" dirty="0"/>
+                        <a:rPr lang="en-US" sz="1200" dirty="0">
+                          <a:solidFill>
+                            <a:srgbClr val="000000"/>
+                          </a:solidFill>
+                          <a:latin typeface="Ubuntu"/>
+                        </a:rPr>
                         <a:t>56 </a:t>
                       </a:r>
                       <a:endParaRPr lang="en-US" sz="1200" dirty="0"/>
@@ -11742,7 +12503,12 @@
                         <a:buNone/>
                       </a:pPr>
                       <a:r>
-                        <a:rPr lang="en-US" sz="1200" dirty="0"/>
+                        <a:rPr lang="en-US" sz="1200" dirty="0">
+                          <a:solidFill>
+                            <a:srgbClr val="000000"/>
+                          </a:solidFill>
+                          <a:latin typeface="Ubuntu"/>
+                        </a:rPr>
                         <a:t>— </a:t>
                       </a:r>
                       <a:endParaRPr lang="en-US" sz="1200" dirty="0"/>
@@ -11850,7 +12616,12 @@
                         <a:buNone/>
                       </a:pPr>
                       <a:r>
-                        <a:rPr lang="en-US" sz="1200" dirty="0"/>
+                        <a:rPr lang="en-US" sz="1200" dirty="0">
+                          <a:solidFill>
+                            <a:srgbClr val="000000"/>
+                          </a:solidFill>
+                          <a:latin typeface="Ubuntu"/>
+                        </a:rPr>
                         <a:t>Point D </a:t>
                       </a:r>
                       <a:endParaRPr lang="en-US" sz="1200" dirty="0"/>
@@ -11888,7 +12659,12 @@
                         <a:buNone/>
                       </a:pPr>
                       <a:r>
-                        <a:rPr lang="en-US" sz="1200" dirty="0"/>
+                        <a:rPr lang="en-US" sz="1200" dirty="0">
+                          <a:solidFill>
+                            <a:srgbClr val="000000"/>
+                          </a:solidFill>
+                          <a:latin typeface="Ubuntu"/>
+                        </a:rPr>
                         <a:t>37 </a:t>
                       </a:r>
                       <a:endParaRPr lang="en-US" sz="1200" dirty="0"/>
@@ -11926,7 +12702,12 @@
                         <a:buNone/>
                       </a:pPr>
                       <a:r>
-                        <a:rPr lang="en-US" sz="1200" dirty="0"/>
+                        <a:rPr lang="en-US" sz="1200" dirty="0">
+                          <a:solidFill>
+                            <a:srgbClr val="000000"/>
+                          </a:solidFill>
+                          <a:latin typeface="Ubuntu"/>
+                        </a:rPr>
                         <a:t>32 </a:t>
                       </a:r>
                       <a:endParaRPr lang="en-US" sz="1200" dirty="0"/>
@@ -11964,7 +12745,12 @@
                         <a:buNone/>
                       </a:pPr>
                       <a:r>
-                        <a:rPr lang="en-US" sz="1200" dirty="0"/>
+                        <a:rPr lang="en-US" sz="1200" dirty="0">
+                          <a:solidFill>
+                            <a:srgbClr val="000000"/>
+                          </a:solidFill>
+                          <a:latin typeface="Ubuntu"/>
+                        </a:rPr>
                         <a:t>91 </a:t>
                       </a:r>
                       <a:endParaRPr lang="en-US" sz="1200" dirty="0"/>
@@ -12002,7 +12788,12 @@
                         <a:buNone/>
                       </a:pPr>
                       <a:r>
-                        <a:rPr lang="en-US" sz="1200" dirty="0"/>
+                        <a:rPr lang="en-US" sz="1200" dirty="0">
+                          <a:solidFill>
+                            <a:srgbClr val="000000"/>
+                          </a:solidFill>
+                          <a:latin typeface="Ubuntu"/>
+                        </a:rPr>
                         <a:t>— </a:t>
                       </a:r>
                       <a:endParaRPr lang="en-US" sz="1200" dirty="0"/>
@@ -12076,7 +12867,12 @@
                         <a:buNone/>
                       </a:pPr>
                       <a:r>
-                        <a:rPr lang="en-US" sz="1200" dirty="0"/>
+                        <a:rPr lang="en-US" sz="1200" dirty="0">
+                          <a:solidFill>
+                            <a:srgbClr val="000000"/>
+                          </a:solidFill>
+                          <a:latin typeface="Ubuntu"/>
+                        </a:rPr>
                         <a:t>Point E </a:t>
                       </a:r>
                       <a:endParaRPr lang="en-US" sz="1200" dirty="0"/>
@@ -12114,7 +12910,12 @@
                         <a:buNone/>
                       </a:pPr>
                       <a:r>
-                        <a:rPr lang="en-US" sz="1200" dirty="0"/>
+                        <a:rPr lang="en-US" sz="1200" dirty="0">
+                          <a:solidFill>
+                            <a:srgbClr val="000000"/>
+                          </a:solidFill>
+                          <a:latin typeface="Ubuntu"/>
+                        </a:rPr>
                         <a:t>93 </a:t>
                       </a:r>
                       <a:endParaRPr lang="en-US" sz="1200" dirty="0"/>
@@ -12152,7 +12953,12 @@
                         <a:buNone/>
                       </a:pPr>
                       <a:r>
-                        <a:rPr lang="en-US" sz="1200" dirty="0"/>
+                        <a:rPr lang="en-US" sz="1200" dirty="0">
+                          <a:solidFill>
+                            <a:srgbClr val="000000"/>
+                          </a:solidFill>
+                          <a:latin typeface="Ubuntu"/>
+                        </a:rPr>
                         <a:t>35 </a:t>
                       </a:r>
                       <a:endParaRPr lang="en-US" sz="1200" dirty="0"/>
@@ -12190,7 +12996,12 @@
                         <a:buNone/>
                       </a:pPr>
                       <a:r>
-                        <a:rPr lang="en-US" sz="1200" dirty="0"/>
+                        <a:rPr lang="en-US" sz="1200" dirty="0">
+                          <a:solidFill>
+                            <a:srgbClr val="000000"/>
+                          </a:solidFill>
+                          <a:latin typeface="Ubuntu"/>
+                        </a:rPr>
                         <a:t>54 </a:t>
                       </a:r>
                       <a:endParaRPr lang="en-US" sz="1200" dirty="0"/>
@@ -12228,7 +13039,12 @@
                         <a:buNone/>
                       </a:pPr>
                       <a:r>
-                        <a:rPr lang="en-US" sz="1200" dirty="0"/>
+                        <a:rPr lang="en-US" sz="1200" dirty="0">
+                          <a:solidFill>
+                            <a:srgbClr val="000000"/>
+                          </a:solidFill>
+                          <a:latin typeface="Ubuntu"/>
+                        </a:rPr>
                         <a:t>43 </a:t>
                       </a:r>
                       <a:endParaRPr lang="en-US" sz="1200" dirty="0"/>
@@ -12266,7 +13082,12 @@
                         <a:buNone/>
                       </a:pPr>
                       <a:r>
-                        <a:rPr lang="en-US" sz="1200" dirty="0"/>
+                        <a:rPr lang="en-US" sz="1200" dirty="0">
+                          <a:solidFill>
+                            <a:srgbClr val="000000"/>
+                          </a:solidFill>
+                          <a:latin typeface="Ubuntu"/>
+                        </a:rPr>
                         <a:t>— </a:t>
                       </a:r>
                       <a:endParaRPr lang="en-US" sz="1200" dirty="0"/>
@@ -12393,7 +13214,12 @@
                         <a:buNone/>
                       </a:pPr>
                       <a:r>
-                        <a:rPr lang="en-US" sz="1200" dirty="0"/>
+                        <a:rPr lang="en-US" sz="1200" dirty="0">
+                          <a:solidFill>
+                            <a:srgbClr val="000000"/>
+                          </a:solidFill>
+                          <a:latin typeface="Ubuntu"/>
+                        </a:rPr>
                         <a:t>Next, we see a table with special formatting in various locations. Notice how the formatting for the header row and sub header rows is preserved. </a:t>
                       </a:r>
                       <a:endParaRPr lang="en-US" sz="1200" dirty="0"/>
@@ -12520,7 +13346,12 @@
                         <a:buNone/>
                       </a:pPr>
                       <a:r>
-                        <a:rPr lang="en-US" sz="1200" dirty="0"/>
+                        <a:rPr lang="en-US" sz="1200" b="1" dirty="0">
+                          <a:solidFill>
+                            <a:srgbClr val="FFFFFF"/>
+                          </a:solidFill>
+                          <a:latin typeface="Ubuntu"/>
+                        </a:rPr>
                         <a:t>College </a:t>
                       </a:r>
                       <a:endParaRPr lang="en-US" sz="1200" dirty="0"/>
@@ -12558,7 +13389,12 @@
                         <a:buNone/>
                       </a:pPr>
                       <a:r>
-                        <a:rPr lang="en-US" sz="1200" dirty="0"/>
+                        <a:rPr lang="en-US" sz="1200" b="1" dirty="0">
+                          <a:solidFill>
+                            <a:srgbClr val="FFFFFF"/>
+                          </a:solidFill>
+                          <a:latin typeface="Ubuntu"/>
+                        </a:rPr>
                         <a:t>New students </a:t>
                       </a:r>
                       <a:endParaRPr lang="en-US" sz="1200" dirty="0"/>
@@ -12596,7 +13432,12 @@
                         <a:buNone/>
                       </a:pPr>
                       <a:r>
-                        <a:rPr lang="en-US" sz="1200" dirty="0"/>
+                        <a:rPr lang="en-US" sz="1200" b="1" dirty="0">
+                          <a:solidFill>
+                            <a:srgbClr val="FFFFFF"/>
+                          </a:solidFill>
+                          <a:latin typeface="Ubuntu"/>
+                        </a:rPr>
                         <a:t>Graduating students </a:t>
                       </a:r>
                       <a:endParaRPr lang="en-US" sz="1200" dirty="0"/>
@@ -12634,7 +13475,12 @@
                         <a:buNone/>
                       </a:pPr>
                       <a:r>
-                        <a:rPr lang="en-US" sz="1200" dirty="0"/>
+                        <a:rPr lang="en-US" sz="1200" b="1" dirty="0">
+                          <a:solidFill>
+                            <a:srgbClr val="FFFFFF"/>
+                          </a:solidFill>
+                          <a:latin typeface="Ubuntu"/>
+                        </a:rPr>
                         <a:t>Change </a:t>
                       </a:r>
                       <a:endParaRPr lang="en-US" sz="1200" dirty="0"/>
@@ -12708,7 +13554,12 @@
                         <a:buNone/>
                       </a:pPr>
                       <a:r>
-                        <a:rPr lang="en-US" sz="1200" dirty="0"/>
+                        <a:rPr lang="en-US" sz="1200" i="1" dirty="0">
+                          <a:solidFill>
+                            <a:srgbClr val="808080"/>
+                          </a:solidFill>
+                          <a:latin typeface="Ubuntu"/>
+                        </a:rPr>
                         <a:t>Undergraduate</a:t>
                       </a:r>
                       <a:r>
@@ -12825,7 +13676,12 @@
                         <a:buNone/>
                       </a:pPr>
                       <a:r>
-                        <a:rPr lang="en-US" sz="1200" dirty="0"/>
+                        <a:rPr lang="en-US" sz="1200" dirty="0">
+                          <a:solidFill>
+                            <a:srgbClr val="000000"/>
+                          </a:solidFill>
+                          <a:latin typeface="Ubuntu"/>
+                        </a:rPr>
                         <a:t>Cedar University </a:t>
                       </a:r>
                       <a:endParaRPr lang="en-US" sz="1200" dirty="0"/>
@@ -12863,7 +13719,12 @@
                         <a:buNone/>
                       </a:pPr>
                       <a:r>
-                        <a:rPr lang="en-US" sz="1200" dirty="0"/>
+                        <a:rPr lang="en-US" sz="1200" dirty="0">
+                          <a:solidFill>
+                            <a:srgbClr val="000000"/>
+                          </a:solidFill>
+                          <a:latin typeface="Ubuntu"/>
+                        </a:rPr>
                         <a:t>110 </a:t>
                       </a:r>
                       <a:endParaRPr lang="en-US" sz="1200" dirty="0"/>
@@ -12901,7 +13762,12 @@
                         <a:buNone/>
                       </a:pPr>
                       <a:r>
-                        <a:rPr lang="en-US" sz="1200" dirty="0"/>
+                        <a:rPr lang="en-US" sz="1200" dirty="0">
+                          <a:solidFill>
+                            <a:srgbClr val="000000"/>
+                          </a:solidFill>
+                          <a:latin typeface="Ubuntu"/>
+                        </a:rPr>
                         <a:t>103 </a:t>
                       </a:r>
                       <a:endParaRPr lang="en-US" sz="1200" dirty="0"/>
@@ -12939,7 +13805,12 @@
                         <a:buNone/>
                       </a:pPr>
                       <a:r>
-                        <a:rPr lang="en-US" sz="1200" dirty="0"/>
+                        <a:rPr lang="en-US" sz="1200" dirty="0">
+                          <a:solidFill>
+                            <a:srgbClr val="000000"/>
+                          </a:solidFill>
+                          <a:latin typeface="Ubuntu"/>
+                        </a:rPr>
                         <a:t>+7 </a:t>
                       </a:r>
                       <a:endParaRPr lang="en-US" sz="1200" dirty="0"/>
@@ -12979,7 +13850,12 @@
                         <a:buNone/>
                       </a:pPr>
                       <a:r>
-                        <a:rPr lang="en-US" sz="1200" dirty="0"/>
+                        <a:rPr lang="en-US" sz="1200" dirty="0">
+                          <a:solidFill>
+                            <a:srgbClr val="000000"/>
+                          </a:solidFill>
+                          <a:latin typeface="Ubuntu"/>
+                        </a:rPr>
                         <a:t>Oak Institute </a:t>
                       </a:r>
                       <a:endParaRPr lang="en-US" sz="1200" dirty="0"/>
@@ -13017,7 +13893,12 @@
                         <a:buNone/>
                       </a:pPr>
                       <a:r>
-                        <a:rPr lang="en-US" sz="1200" dirty="0"/>
+                        <a:rPr lang="en-US" sz="1200" dirty="0">
+                          <a:solidFill>
+                            <a:srgbClr val="000000"/>
+                          </a:solidFill>
+                          <a:latin typeface="Ubuntu"/>
+                        </a:rPr>
                         <a:t>202 </a:t>
                       </a:r>
                       <a:endParaRPr lang="en-US" sz="1200" dirty="0"/>
@@ -13055,7 +13936,12 @@
                         <a:buNone/>
                       </a:pPr>
                       <a:r>
-                        <a:rPr lang="en-US" sz="1200" dirty="0"/>
+                        <a:rPr lang="en-US" sz="1200" dirty="0">
+                          <a:solidFill>
+                            <a:srgbClr val="000000"/>
+                          </a:solidFill>
+                          <a:latin typeface="Ubuntu"/>
+                        </a:rPr>
                         <a:t>210 </a:t>
                       </a:r>
                       <a:endParaRPr lang="en-US" sz="1200" dirty="0"/>
@@ -13093,7 +13979,12 @@
                         <a:buNone/>
                       </a:pPr>
                       <a:r>
-                        <a:rPr lang="en-US" sz="1200" dirty="0"/>
+                        <a:rPr lang="en-US" sz="1200" dirty="0">
+                          <a:solidFill>
+                            <a:srgbClr val="000000"/>
+                          </a:solidFill>
+                          <a:latin typeface="Ubuntu"/>
+                        </a:rPr>
                         <a:t>-8 </a:t>
                       </a:r>
                       <a:endParaRPr lang="en-US" sz="1200" dirty="0"/>
@@ -13167,7 +14058,12 @@
                         <a:buNone/>
                       </a:pPr>
                       <a:r>
-                        <a:rPr lang="en-US" sz="1200" dirty="0"/>
+                        <a:rPr lang="en-US" sz="1200" i="1" dirty="0">
+                          <a:solidFill>
+                            <a:srgbClr val="808080"/>
+                          </a:solidFill>
+                          <a:latin typeface="Ubuntu"/>
+                        </a:rPr>
                         <a:t>Graduate</a:t>
                       </a:r>
                       <a:r>
@@ -13284,7 +14180,12 @@
                         <a:buNone/>
                       </a:pPr>
                       <a:r>
-                        <a:rPr lang="en-US" sz="1200" dirty="0"/>
+                        <a:rPr lang="en-US" sz="1200" dirty="0">
+                          <a:solidFill>
+                            <a:srgbClr val="000000"/>
+                          </a:solidFill>
+                          <a:latin typeface="Ubuntu"/>
+                        </a:rPr>
                         <a:t>Cedar University </a:t>
                       </a:r>
                       <a:endParaRPr lang="en-US" sz="1200" dirty="0"/>
@@ -13322,7 +14223,12 @@
                         <a:buNone/>
                       </a:pPr>
                       <a:r>
-                        <a:rPr lang="en-US" sz="1200" dirty="0"/>
+                        <a:rPr lang="en-US" sz="1200" dirty="0">
+                          <a:solidFill>
+                            <a:srgbClr val="000000"/>
+                          </a:solidFill>
+                          <a:latin typeface="Ubuntu"/>
+                        </a:rPr>
                         <a:t>24 </a:t>
                       </a:r>
                       <a:endParaRPr lang="en-US" sz="1200" dirty="0"/>
@@ -13360,7 +14266,12 @@
                         <a:buNone/>
                       </a:pPr>
                       <a:r>
-                        <a:rPr lang="en-US" sz="1200" dirty="0"/>
+                        <a:rPr lang="en-US" sz="1200" dirty="0">
+                          <a:solidFill>
+                            <a:srgbClr val="000000"/>
+                          </a:solidFill>
+                          <a:latin typeface="Ubuntu"/>
+                        </a:rPr>
                         <a:t>20 </a:t>
                       </a:r>
                       <a:endParaRPr lang="en-US" sz="1200" dirty="0"/>
@@ -13398,7 +14309,12 @@
                         <a:buNone/>
                       </a:pPr>
                       <a:r>
-                        <a:rPr lang="en-US" sz="1200" dirty="0"/>
+                        <a:rPr lang="en-US" sz="1200" dirty="0">
+                          <a:solidFill>
+                            <a:srgbClr val="000000"/>
+                          </a:solidFill>
+                          <a:latin typeface="Ubuntu"/>
+                        </a:rPr>
                         <a:t>+4 </a:t>
                       </a:r>
                       <a:endParaRPr lang="en-US" sz="1200" dirty="0"/>
@@ -13438,7 +14354,12 @@
                         <a:buNone/>
                       </a:pPr>
                       <a:r>
-                        <a:rPr lang="en-US" sz="1200" dirty="0"/>
+                        <a:rPr lang="en-US" sz="1200" dirty="0">
+                          <a:solidFill>
+                            <a:srgbClr val="000000"/>
+                          </a:solidFill>
+                          <a:latin typeface="Ubuntu"/>
+                        </a:rPr>
                         <a:t>Elm College </a:t>
                       </a:r>
                       <a:endParaRPr lang="en-US" sz="1200" dirty="0"/>
@@ -13476,7 +14397,12 @@
                         <a:buNone/>
                       </a:pPr>
                       <a:r>
-                        <a:rPr lang="en-US" sz="1200" dirty="0"/>
+                        <a:rPr lang="en-US" sz="1200" dirty="0">
+                          <a:solidFill>
+                            <a:srgbClr val="000000"/>
+                          </a:solidFill>
+                          <a:latin typeface="Ubuntu"/>
+                        </a:rPr>
                         <a:t>43 </a:t>
                       </a:r>
                       <a:endParaRPr lang="en-US" sz="1200" dirty="0"/>
@@ -13514,7 +14440,12 @@
                         <a:buNone/>
                       </a:pPr>
                       <a:r>
-                        <a:rPr lang="en-US" sz="1200" dirty="0"/>
+                        <a:rPr lang="en-US" sz="1200" dirty="0">
+                          <a:solidFill>
+                            <a:srgbClr val="000000"/>
+                          </a:solidFill>
+                          <a:latin typeface="Ubuntu"/>
+                        </a:rPr>
                         <a:t>53 </a:t>
                       </a:r>
                       <a:endParaRPr lang="en-US" sz="1200" dirty="0"/>
@@ -13552,7 +14483,12 @@
                         <a:buNone/>
                       </a:pPr>
                       <a:r>
-                        <a:rPr lang="en-US" sz="1200" dirty="0"/>
+                        <a:rPr lang="en-US" sz="1200" dirty="0">
+                          <a:solidFill>
+                            <a:srgbClr val="000000"/>
+                          </a:solidFill>
+                          <a:latin typeface="Ubuntu"/>
+                        </a:rPr>
                         <a:t>-10 </a:t>
                       </a:r>
                       <a:endParaRPr lang="en-US" sz="1200" dirty="0"/>
@@ -13592,7 +14528,12 @@
                         <a:buNone/>
                       </a:pPr>
                       <a:r>
-                        <a:rPr lang="en-US" sz="1200" dirty="0"/>
+                        <a:rPr lang="en-US" sz="1200" dirty="0">
+                          <a:solidFill>
+                            <a:srgbClr val="000000"/>
+                          </a:solidFill>
+                          <a:latin typeface="Ubuntu"/>
+                        </a:rPr>
                         <a:t>Total </a:t>
                       </a:r>
                       <a:endParaRPr lang="en-US" sz="1200" dirty="0"/>
@@ -13630,7 +14571,12 @@
                         <a:buNone/>
                       </a:pPr>
                       <a:r>
-                        <a:rPr lang="en-US" sz="1200" dirty="0"/>
+                        <a:rPr lang="en-US" sz="1200" dirty="0">
+                          <a:solidFill>
+                            <a:srgbClr val="000000"/>
+                          </a:solidFill>
+                          <a:latin typeface="Ubuntu"/>
+                        </a:rPr>
                         <a:t>998 </a:t>
                       </a:r>
                       <a:endParaRPr lang="en-US" sz="1200" dirty="0"/>
@@ -13668,7 +14614,12 @@
                         <a:buNone/>
                       </a:pPr>
                       <a:r>
-                        <a:rPr lang="en-US" sz="1200" dirty="0"/>
+                        <a:rPr lang="en-US" sz="1200" dirty="0">
+                          <a:solidFill>
+                            <a:srgbClr val="000000"/>
+                          </a:solidFill>
+                          <a:latin typeface="Ubuntu"/>
+                        </a:rPr>
                         <a:t>908 </a:t>
                       </a:r>
                       <a:endParaRPr lang="en-US" sz="1200" dirty="0"/>
@@ -13706,7 +14657,12 @@
                         <a:buNone/>
                       </a:pPr>
                       <a:r>
-                        <a:rPr lang="en-US" sz="1200" dirty="0"/>
+                        <a:rPr lang="en-US" sz="1200" dirty="0">
+                          <a:solidFill>
+                            <a:srgbClr val="000000"/>
+                          </a:solidFill>
+                          <a:latin typeface="Ubuntu"/>
+                        </a:rPr>
                         <a:t>90 </a:t>
                       </a:r>
                       <a:endParaRPr lang="en-US" sz="1200" dirty="0"/>
@@ -13746,7 +14702,12 @@
                         <a:buNone/>
                       </a:pPr>
                       <a:r>
-                        <a:rPr lang="en-US" sz="1200" dirty="0"/>
+                        <a:rPr lang="en-US" sz="1000" i="1" dirty="0">
+                          <a:solidFill>
+                            <a:srgbClr val="808080"/>
+                          </a:solidFill>
+                          <a:latin typeface="Ubuntu"/>
+                        </a:rPr>
                         <a:t>Source:</a:t>
                       </a:r>
                       <a:r>
@@ -13882,7 +14843,12 @@
                         <a:buNone/>
                       </a:pPr>
                       <a:r>
-                        <a:rPr lang="en-US" sz="1200" dirty="0"/>
+                        <a:rPr lang="en-US" sz="1200" dirty="0">
+                          <a:solidFill>
+                            <a:srgbClr val="000000"/>
+                          </a:solidFill>
+                          <a:latin typeface="Ubuntu"/>
+                        </a:rPr>
                         <a:t>Next, we have something a little more complex, a nested table, i.e. a table inside another table. Additionally, the inner table has some of its cells merged. The table is displayed horizontally centered. </a:t>
                       </a:r>
                       <a:endParaRPr lang="en-US" sz="1200" dirty="0"/>
@@ -14096,7 +15062,12 @@
                         <a:buNone/>
                       </a:pPr>
                       <a:r>
-                        <a:rPr lang="en-US" sz="1200" dirty="0"/>
+                        <a:rPr lang="en-US" sz="1200" dirty="0">
+                          <a:solidFill>
+                            <a:srgbClr val="000000"/>
+                          </a:solidFill>
+                          <a:latin typeface="Ubuntu"/>
+                        </a:rPr>
                         <a:t>Next, we see a table with special formatting in various locations. Notice how the formatting for the header row and sub header rows is preserved. </a:t>
                       </a:r>
                       <a:endParaRPr lang="en-US" sz="1200" dirty="0"/>
@@ -14223,7 +15194,12 @@
                         <a:buNone/>
                       </a:pPr>
                       <a:r>
-                        <a:rPr lang="en-US" sz="1200" dirty="0"/>
+                        <a:rPr lang="en-US" sz="1200" dirty="0">
+                          <a:solidFill>
+                            <a:srgbClr val="000000"/>
+                          </a:solidFill>
+                          <a:latin typeface="Ubuntu"/>
+                        </a:rPr>
                         <a:t>One </a:t>
                       </a:r>
                       <a:endParaRPr lang="en-US" sz="1200" dirty="0"/>
@@ -14261,7 +15237,12 @@
                         <a:buNone/>
                       </a:pPr>
                       <a:r>
-                        <a:rPr lang="en-US" sz="1200" dirty="0"/>
+                        <a:rPr lang="en-US" sz="1200" dirty="0">
+                          <a:solidFill>
+                            <a:srgbClr val="000000"/>
+                          </a:solidFill>
+                          <a:latin typeface="Ubuntu"/>
+                        </a:rPr>
                         <a:t>Two </a:t>
                       </a:r>
                       <a:endParaRPr lang="en-US" sz="1200" dirty="0"/>
@@ -14299,7 +15280,12 @@
                         <a:buNone/>
                       </a:pPr>
                       <a:r>
-                        <a:rPr lang="en-US" sz="1200" dirty="0"/>
+                        <a:rPr lang="en-US" sz="1200" dirty="0">
+                          <a:solidFill>
+                            <a:srgbClr val="000000"/>
+                          </a:solidFill>
+                          <a:latin typeface="Ubuntu"/>
+                        </a:rPr>
                         <a:t>To the left is a table inside a table, with some cells merged. </a:t>
                       </a:r>
                       <a:endParaRPr lang="en-US" sz="1200" dirty="0"/>
@@ -14368,7 +15354,12 @@
                         <a:buNone/>
                       </a:pPr>
                       <a:r>
-                        <a:rPr lang="en-US" sz="1200" dirty="0"/>
+                        <a:rPr lang="en-US" sz="1200" dirty="0">
+                          <a:solidFill>
+                            <a:srgbClr val="000000"/>
+                          </a:solidFill>
+                          <a:latin typeface="Ubuntu"/>
+                        </a:rPr>
                         <a:t>Three </a:t>
                       </a:r>
                       <a:endParaRPr lang="en-US" sz="1200" dirty="0"/>
@@ -14524,7 +15515,12 @@
                         <a:buNone/>
                       </a:pPr>
                       <a:r>
-                        <a:rPr lang="en-US" sz="1200" dirty="0"/>
+                        <a:rPr lang="en-US" sz="1200" dirty="0">
+                          <a:solidFill>
+                            <a:srgbClr val="000000"/>
+                          </a:solidFill>
+                          <a:latin typeface="Ubuntu"/>
+                        </a:rPr>
                         <a:t>Four </a:t>
                       </a:r>
                       <a:endParaRPr lang="en-US" sz="1200" dirty="0"/>
@@ -14842,7 +15838,12 @@
                         <a:buNone/>
                       </a:pPr>
                       <a:r>
-                        <a:rPr lang="en-US" sz="1200" dirty="0"/>
+                        <a:rPr lang="en-US" sz="1200" dirty="0">
+                          <a:solidFill>
+                            <a:srgbClr val="000000"/>
+                          </a:solidFill>
+                          <a:latin typeface="Ubuntu"/>
+                        </a:rPr>
                         <a:t>We end with a fancy calendar, note how much of the original formatting is preserved. Note that this table will only display correctly on relatively wide screens. In general, very wide tables or tables whose cells have fixed width requirements don’t fare well in ebooks. </a:t>
                       </a:r>
                       <a:endParaRPr lang="en-US" sz="1200" dirty="0"/>
@@ -15259,7 +16260,12 @@
                         <a:buNone/>
                       </a:pPr>
                       <a:r>
-                        <a:rPr lang="en-US" sz="1200" dirty="0"/>
+                        <a:rPr lang="en-US" sz="1200" dirty="0">
+                          <a:solidFill>
+                            <a:srgbClr val="365F91"/>
+                          </a:solidFill>
+                          <a:latin typeface="Ubuntu"/>
+                        </a:rPr>
                         <a:t>December 2007 </a:t>
                       </a:r>
                       <a:endParaRPr lang="en-US" sz="1200" dirty="0"/>
@@ -15676,7 +16682,12 @@
                         <a:buNone/>
                       </a:pPr>
                       <a:r>
-                        <a:rPr lang="en-US" sz="1200" dirty="0"/>
+                        <a:rPr lang="en-US" sz="1200" dirty="0">
+                          <a:solidFill>
+                            <a:srgbClr val="365F91"/>
+                          </a:solidFill>
+                          <a:latin typeface="Ubuntu"/>
+                        </a:rPr>
                         <a:t>Sun </a:t>
                       </a:r>
                       <a:endParaRPr lang="en-US" sz="1200" dirty="0"/>
@@ -15748,7 +16759,12 @@
                         <a:buNone/>
                       </a:pPr>
                       <a:r>
-                        <a:rPr lang="en-US" sz="1200" dirty="0"/>
+                        <a:rPr lang="en-US" sz="1200" dirty="0">
+                          <a:solidFill>
+                            <a:srgbClr val="7F7F7F"/>
+                          </a:solidFill>
+                          <a:latin typeface="Ubuntu"/>
+                        </a:rPr>
                         <a:t>Mon </a:t>
                       </a:r>
                       <a:endParaRPr lang="en-US" sz="1200" dirty="0"/>
@@ -15820,7 +16836,12 @@
                         <a:buNone/>
                       </a:pPr>
                       <a:r>
-                        <a:rPr lang="en-US" sz="1200" dirty="0"/>
+                        <a:rPr lang="en-US" sz="1200" dirty="0">
+                          <a:solidFill>
+                            <a:srgbClr val="7F7F7F"/>
+                          </a:solidFill>
+                          <a:latin typeface="Ubuntu"/>
+                        </a:rPr>
                         <a:t>Tue </a:t>
                       </a:r>
                       <a:endParaRPr lang="en-US" sz="1200" dirty="0"/>
@@ -15892,7 +16913,12 @@
                         <a:buNone/>
                       </a:pPr>
                       <a:r>
-                        <a:rPr lang="en-US" sz="1200" dirty="0"/>
+                        <a:rPr lang="en-US" sz="1200" dirty="0">
+                          <a:solidFill>
+                            <a:srgbClr val="7F7F7F"/>
+                          </a:solidFill>
+                          <a:latin typeface="Ubuntu"/>
+                        </a:rPr>
                         <a:t>Wed </a:t>
                       </a:r>
                       <a:endParaRPr lang="en-US" sz="1200" dirty="0"/>
@@ -15964,7 +16990,12 @@
                         <a:buNone/>
                       </a:pPr>
                       <a:r>
-                        <a:rPr lang="en-US" sz="1200" dirty="0"/>
+                        <a:rPr lang="en-US" sz="1200" dirty="0">
+                          <a:solidFill>
+                            <a:srgbClr val="7F7F7F"/>
+                          </a:solidFill>
+                          <a:latin typeface="Ubuntu"/>
+                        </a:rPr>
                         <a:t>Thu </a:t>
                       </a:r>
                       <a:endParaRPr lang="en-US" sz="1200" dirty="0"/>
@@ -16036,7 +17067,12 @@
                         <a:buNone/>
                       </a:pPr>
                       <a:r>
-                        <a:rPr lang="en-US" sz="1200" dirty="0"/>
+                        <a:rPr lang="en-US" sz="1200" dirty="0">
+                          <a:solidFill>
+                            <a:srgbClr val="7F7F7F"/>
+                          </a:solidFill>
+                          <a:latin typeface="Ubuntu"/>
+                        </a:rPr>
                         <a:t>Fri </a:t>
                       </a:r>
                       <a:endParaRPr lang="en-US" sz="1200" dirty="0"/>
@@ -16108,7 +17144,12 @@
                         <a:buNone/>
                       </a:pPr>
                       <a:r>
-                        <a:rPr lang="en-US" sz="1200" dirty="0"/>
+                        <a:rPr lang="en-US" sz="1200" dirty="0">
+                          <a:solidFill>
+                            <a:srgbClr val="7F7F7F"/>
+                          </a:solidFill>
+                          <a:latin typeface="Ubuntu"/>
+                        </a:rPr>
                         <a:t>Sat </a:t>
                       </a:r>
                       <a:endParaRPr lang="en-US" sz="1200" dirty="0"/>
@@ -16585,7 +17626,12 @@
                         <a:buNone/>
                       </a:pPr>
                       <a:r>
-                        <a:rPr lang="en-US" sz="1200" dirty="0"/>
+                        <a:rPr lang="en-US" sz="1200" dirty="0">
+                          <a:solidFill>
+                            <a:srgbClr val="7F7F7F"/>
+                          </a:solidFill>
+                          <a:latin typeface="Ubuntu"/>
+                        </a:rPr>
                         <a:t>1 </a:t>
                       </a:r>
                       <a:endParaRPr lang="en-US" sz="1200" dirty="0"/>
@@ -17127,7 +18173,12 @@
                         <a:buNone/>
                       </a:pPr>
                       <a:r>
-                        <a:rPr lang="en-US" sz="1200" dirty="0"/>
+                        <a:rPr lang="en-US" sz="1200" dirty="0">
+                          <a:solidFill>
+                            <a:srgbClr val="365F91"/>
+                          </a:solidFill>
+                          <a:latin typeface="Ubuntu"/>
+                        </a:rPr>
                         <a:t>2 </a:t>
                       </a:r>
                       <a:endParaRPr lang="en-US" sz="1200" dirty="0"/>
@@ -17199,7 +18250,12 @@
                         <a:buNone/>
                       </a:pPr>
                       <a:r>
-                        <a:rPr lang="en-US" sz="1200" dirty="0"/>
+                        <a:rPr lang="en-US" sz="1200" dirty="0">
+                          <a:solidFill>
+                            <a:srgbClr val="7F7F7F"/>
+                          </a:solidFill>
+                          <a:latin typeface="Ubuntu"/>
+                        </a:rPr>
                         <a:t>3 </a:t>
                       </a:r>
                       <a:endParaRPr lang="en-US" sz="1200" dirty="0"/>
@@ -17271,7 +18327,12 @@
                         <a:buNone/>
                       </a:pPr>
                       <a:r>
-                        <a:rPr lang="en-US" sz="1200" dirty="0"/>
+                        <a:rPr lang="en-US" sz="1200" dirty="0">
+                          <a:solidFill>
+                            <a:srgbClr val="7F7F7F"/>
+                          </a:solidFill>
+                          <a:latin typeface="Ubuntu"/>
+                        </a:rPr>
                         <a:t>4 </a:t>
                       </a:r>
                       <a:endParaRPr lang="en-US" sz="1200" dirty="0"/>
@@ -17343,7 +18404,12 @@
                         <a:buNone/>
                       </a:pPr>
                       <a:r>
-                        <a:rPr lang="en-US" sz="1200" dirty="0"/>
+                        <a:rPr lang="en-US" sz="1200" dirty="0">
+                          <a:solidFill>
+                            <a:srgbClr val="7F7F7F"/>
+                          </a:solidFill>
+                          <a:latin typeface="Ubuntu"/>
+                        </a:rPr>
                         <a:t>5 </a:t>
                       </a:r>
                       <a:endParaRPr lang="en-US" sz="1200" dirty="0"/>
@@ -17415,7 +18481,12 @@
                         <a:buNone/>
                       </a:pPr>
                       <a:r>
-                        <a:rPr lang="en-US" sz="1200" dirty="0"/>
+                        <a:rPr lang="en-US" sz="1200" dirty="0">
+                          <a:solidFill>
+                            <a:srgbClr val="7F7F7F"/>
+                          </a:solidFill>
+                          <a:latin typeface="Ubuntu"/>
+                        </a:rPr>
                         <a:t>6 </a:t>
                       </a:r>
                       <a:endParaRPr lang="en-US" sz="1200" dirty="0"/>
@@ -17487,7 +18558,12 @@
                         <a:buNone/>
                       </a:pPr>
                       <a:r>
-                        <a:rPr lang="en-US" sz="1200" dirty="0"/>
+                        <a:rPr lang="en-US" sz="1200" dirty="0">
+                          <a:solidFill>
+                            <a:srgbClr val="7F7F7F"/>
+                          </a:solidFill>
+                          <a:latin typeface="Ubuntu"/>
+                        </a:rPr>
                         <a:t>7 </a:t>
                       </a:r>
                       <a:endParaRPr lang="en-US" sz="1200" dirty="0"/>
@@ -17559,7 +18635,12 @@
                         <a:buNone/>
                       </a:pPr>
                       <a:r>
-                        <a:rPr lang="en-US" sz="1200" dirty="0"/>
+                        <a:rPr lang="en-US" sz="1200" dirty="0">
+                          <a:solidFill>
+                            <a:srgbClr val="7F7F7F"/>
+                          </a:solidFill>
+                          <a:latin typeface="Ubuntu"/>
+                        </a:rPr>
                         <a:t>8 </a:t>
                       </a:r>
                       <a:endParaRPr lang="en-US" sz="1200" dirty="0"/>
@@ -18101,7 +19182,12 @@
                         <a:buNone/>
                       </a:pPr>
                       <a:r>
-                        <a:rPr lang="en-US" sz="1200" dirty="0"/>
+                        <a:rPr lang="en-US" sz="1200" dirty="0">
+                          <a:solidFill>
+                            <a:srgbClr val="365F91"/>
+                          </a:solidFill>
+                          <a:latin typeface="Ubuntu"/>
+                        </a:rPr>
                         <a:t>9 </a:t>
                       </a:r>
                       <a:endParaRPr lang="en-US" sz="1200" dirty="0"/>
@@ -18173,7 +19259,12 @@
                         <a:buNone/>
                       </a:pPr>
                       <a:r>
-                        <a:rPr lang="en-US" sz="1200" dirty="0"/>
+                        <a:rPr lang="en-US" sz="1200" dirty="0">
+                          <a:solidFill>
+                            <a:srgbClr val="7F7F7F"/>
+                          </a:solidFill>
+                          <a:latin typeface="Ubuntu"/>
+                        </a:rPr>
                         <a:t>10 </a:t>
                       </a:r>
                       <a:endParaRPr lang="en-US" sz="1200" dirty="0"/>
@@ -18245,7 +19336,12 @@
                         <a:buNone/>
                       </a:pPr>
                       <a:r>
-                        <a:rPr lang="en-US" sz="1200" dirty="0"/>
+                        <a:rPr lang="en-US" sz="1200" dirty="0">
+                          <a:solidFill>
+                            <a:srgbClr val="7F7F7F"/>
+                          </a:solidFill>
+                          <a:latin typeface="Ubuntu"/>
+                        </a:rPr>
                         <a:t>11 </a:t>
                       </a:r>
                       <a:endParaRPr lang="en-US" sz="1200" dirty="0"/>
@@ -18317,7 +19413,12 @@
                         <a:buNone/>
                       </a:pPr>
                       <a:r>
-                        <a:rPr lang="en-US" sz="1200" dirty="0"/>
+                        <a:rPr lang="en-US" sz="1200" dirty="0">
+                          <a:solidFill>
+                            <a:srgbClr val="7F7F7F"/>
+                          </a:solidFill>
+                          <a:latin typeface="Ubuntu"/>
+                        </a:rPr>
                         <a:t>12 </a:t>
                       </a:r>
                       <a:endParaRPr lang="en-US" sz="1200" dirty="0"/>
@@ -18389,7 +19490,12 @@
                         <a:buNone/>
                       </a:pPr>
                       <a:r>
-                        <a:rPr lang="en-US" sz="1200" dirty="0"/>
+                        <a:rPr lang="en-US" sz="1200" dirty="0">
+                          <a:solidFill>
+                            <a:srgbClr val="7F7F7F"/>
+                          </a:solidFill>
+                          <a:latin typeface="Ubuntu"/>
+                        </a:rPr>
                         <a:t>13 </a:t>
                       </a:r>
                       <a:endParaRPr lang="en-US" sz="1200" dirty="0"/>
@@ -18461,7 +19567,12 @@
                         <a:buNone/>
                       </a:pPr>
                       <a:r>
-                        <a:rPr lang="en-US" sz="1200" dirty="0"/>
+                        <a:rPr lang="en-US" sz="1200" dirty="0">
+                          <a:solidFill>
+                            <a:srgbClr val="7F7F7F"/>
+                          </a:solidFill>
+                          <a:latin typeface="Ubuntu"/>
+                        </a:rPr>
                         <a:t>14 </a:t>
                       </a:r>
                       <a:endParaRPr lang="en-US" sz="1200" dirty="0"/>
@@ -18533,7 +19644,12 @@
                         <a:buNone/>
                       </a:pPr>
                       <a:r>
-                        <a:rPr lang="en-US" sz="1200" dirty="0"/>
+                        <a:rPr lang="en-US" sz="1200" dirty="0">
+                          <a:solidFill>
+                            <a:srgbClr val="7F7F7F"/>
+                          </a:solidFill>
+                          <a:latin typeface="Ubuntu"/>
+                        </a:rPr>
                         <a:t>15 </a:t>
                       </a:r>
                       <a:endParaRPr lang="en-US" sz="1200" dirty="0"/>
@@ -19075,7 +20191,12 @@
                         <a:buNone/>
                       </a:pPr>
                       <a:r>
-                        <a:rPr lang="en-US" sz="1200" dirty="0"/>
+                        <a:rPr lang="en-US" sz="1200" dirty="0">
+                          <a:solidFill>
+                            <a:srgbClr val="365F91"/>
+                          </a:solidFill>
+                          <a:latin typeface="Ubuntu"/>
+                        </a:rPr>
                         <a:t>16 </a:t>
                       </a:r>
                       <a:endParaRPr lang="en-US" sz="1200" dirty="0"/>
@@ -19147,7 +20268,12 @@
                         <a:buNone/>
                       </a:pPr>
                       <a:r>
-                        <a:rPr lang="en-US" sz="1200" dirty="0"/>
+                        <a:rPr lang="en-US" sz="1200" dirty="0">
+                          <a:solidFill>
+                            <a:srgbClr val="7F7F7F"/>
+                          </a:solidFill>
+                          <a:latin typeface="Ubuntu"/>
+                        </a:rPr>
                         <a:t>17 </a:t>
                       </a:r>
                       <a:endParaRPr lang="en-US" sz="1200" dirty="0"/>
@@ -19219,7 +20345,12 @@
                         <a:buNone/>
                       </a:pPr>
                       <a:r>
-                        <a:rPr lang="en-US" sz="1200" dirty="0"/>
+                        <a:rPr lang="en-US" sz="1200" dirty="0">
+                          <a:solidFill>
+                            <a:srgbClr val="7F7F7F"/>
+                          </a:solidFill>
+                          <a:latin typeface="Ubuntu"/>
+                        </a:rPr>
                         <a:t>18 </a:t>
                       </a:r>
                       <a:endParaRPr lang="en-US" sz="1200" dirty="0"/>
@@ -19291,7 +20422,12 @@
                         <a:buNone/>
                       </a:pPr>
                       <a:r>
-                        <a:rPr lang="en-US" sz="1200" dirty="0"/>
+                        <a:rPr lang="en-US" sz="1200" dirty="0">
+                          <a:solidFill>
+                            <a:srgbClr val="7F7F7F"/>
+                          </a:solidFill>
+                          <a:latin typeface="Ubuntu"/>
+                        </a:rPr>
                         <a:t>19 </a:t>
                       </a:r>
                       <a:endParaRPr lang="en-US" sz="1200" dirty="0"/>
@@ -19363,7 +20499,12 @@
                         <a:buNone/>
                       </a:pPr>
                       <a:r>
-                        <a:rPr lang="en-US" sz="1200" dirty="0"/>
+                        <a:rPr lang="en-US" sz="1200" dirty="0">
+                          <a:solidFill>
+                            <a:srgbClr val="7F7F7F"/>
+                          </a:solidFill>
+                          <a:latin typeface="Ubuntu"/>
+                        </a:rPr>
                         <a:t>20 </a:t>
                       </a:r>
                       <a:endParaRPr lang="en-US" sz="1200" dirty="0"/>
@@ -19435,7 +20576,12 @@
                         <a:buNone/>
                       </a:pPr>
                       <a:r>
-                        <a:rPr lang="en-US" sz="1200" dirty="0"/>
+                        <a:rPr lang="en-US" sz="1200" dirty="0">
+                          <a:solidFill>
+                            <a:srgbClr val="7F7F7F"/>
+                          </a:solidFill>
+                          <a:latin typeface="Ubuntu"/>
+                        </a:rPr>
                         <a:t>21 </a:t>
                       </a:r>
                       <a:endParaRPr lang="en-US" sz="1200" dirty="0"/>
@@ -19507,7 +20653,12 @@
                         <a:buNone/>
                       </a:pPr>
                       <a:r>
-                        <a:rPr lang="en-US" sz="1200" dirty="0"/>
+                        <a:rPr lang="en-US" sz="1200" dirty="0">
+                          <a:solidFill>
+                            <a:srgbClr val="7F7F7F"/>
+                          </a:solidFill>
+                          <a:latin typeface="Ubuntu"/>
+                        </a:rPr>
                         <a:t>22 </a:t>
                       </a:r>
                       <a:endParaRPr lang="en-US" sz="1200" dirty="0"/>

</xml_diff>